<commit_message>
Refactor scenario conversation flow and validation
</commit_message>
<xml_diff>
--- a/outputs/2팀 발표.pptx
+++ b/outputs/2팀 발표.pptx
@@ -2,26 +2,26 @@
 <file path=ppt/presentation.xml><?xml version="1.0" encoding="utf-8"?>
 <p:presentation xmlns:p="http://schemas.openxmlformats.org/presentationml/2006/main">
   <p:sldMasterIdLst>
-    <p:sldMasterId xmlns:r="http://schemas.openxmlformats.org/officeDocument/2006/relationships" id="2147483648" r:id="R893935107ff04445"/>
+    <p:sldMasterId xmlns:r="http://schemas.openxmlformats.org/officeDocument/2006/relationships" id="2147483648" r:id="R0f536048502d42cb"/>
   </p:sldMasterIdLst>
   <p:notesMasterIdLst>
-    <p:notesMasterId xmlns:r="http://schemas.openxmlformats.org/officeDocument/2006/relationships" r:id="Re82873ac913f4145"/>
+    <p:notesMasterId xmlns:r="http://schemas.openxmlformats.org/officeDocument/2006/relationships" r:id="Re8209f55990c4f4a"/>
   </p:notesMasterIdLst>
   <p:sldIdLst>
-    <p:sldId xmlns:r="http://schemas.openxmlformats.org/officeDocument/2006/relationships" id="256" r:id="R80f68968ebe94fc9"/>
-    <p:sldId xmlns:r="http://schemas.openxmlformats.org/officeDocument/2006/relationships" id="257" r:id="Rfaa98b8e8a1c4a38"/>
-    <p:sldId xmlns:r="http://schemas.openxmlformats.org/officeDocument/2006/relationships" id="258" r:id="R0ad18edb62cc4690"/>
-    <p:sldId xmlns:r="http://schemas.openxmlformats.org/officeDocument/2006/relationships" id="259" r:id="R2c92ece22d254c16"/>
-    <p:sldId xmlns:r="http://schemas.openxmlformats.org/officeDocument/2006/relationships" id="260" r:id="R34bf66d220b4460a"/>
-    <p:sldId xmlns:r="http://schemas.openxmlformats.org/officeDocument/2006/relationships" id="261" r:id="R486e2cf3b7574f94"/>
-    <p:sldId xmlns:r="http://schemas.openxmlformats.org/officeDocument/2006/relationships" id="262" r:id="R1f09d740f2b1401f"/>
-    <p:sldId xmlns:r="http://schemas.openxmlformats.org/officeDocument/2006/relationships" id="263" r:id="Rf8724ebd47a24b11"/>
-    <p:sldId xmlns:r="http://schemas.openxmlformats.org/officeDocument/2006/relationships" id="264" r:id="Rf9964e75b5654b33"/>
-    <p:sldId xmlns:r="http://schemas.openxmlformats.org/officeDocument/2006/relationships" id="265" r:id="Rbc6950a6d98946d5"/>
-    <p:sldId xmlns:r="http://schemas.openxmlformats.org/officeDocument/2006/relationships" id="266" r:id="Ra29f3fc0d9e24287"/>
-    <p:sldId xmlns:r="http://schemas.openxmlformats.org/officeDocument/2006/relationships" id="267" r:id="R097730b24fc04f34"/>
-    <p:sldId xmlns:r="http://schemas.openxmlformats.org/officeDocument/2006/relationships" id="268" r:id="R109b1d3346a042c1"/>
-    <p:sldId xmlns:r="http://schemas.openxmlformats.org/officeDocument/2006/relationships" id="269" r:id="R6c8debf680174f82"/>
+    <p:sldId xmlns:r="http://schemas.openxmlformats.org/officeDocument/2006/relationships" id="256" r:id="R392d7438f7b74ba5"/>
+    <p:sldId xmlns:r="http://schemas.openxmlformats.org/officeDocument/2006/relationships" id="257" r:id="R6f87c073bab449b6"/>
+    <p:sldId xmlns:r="http://schemas.openxmlformats.org/officeDocument/2006/relationships" id="258" r:id="R8b6fb50dc03448a5"/>
+    <p:sldId xmlns:r="http://schemas.openxmlformats.org/officeDocument/2006/relationships" id="259" r:id="R186d731948084d46"/>
+    <p:sldId xmlns:r="http://schemas.openxmlformats.org/officeDocument/2006/relationships" id="260" r:id="Re9229f5081e54ff1"/>
+    <p:sldId xmlns:r="http://schemas.openxmlformats.org/officeDocument/2006/relationships" id="261" r:id="R758eff6d4b1c410a"/>
+    <p:sldId xmlns:r="http://schemas.openxmlformats.org/officeDocument/2006/relationships" id="262" r:id="Ra12511bb71a84bc9"/>
+    <p:sldId xmlns:r="http://schemas.openxmlformats.org/officeDocument/2006/relationships" id="263" r:id="Re17e37b2c74b449a"/>
+    <p:sldId xmlns:r="http://schemas.openxmlformats.org/officeDocument/2006/relationships" id="264" r:id="R1caf2bd7ad9f4a43"/>
+    <p:sldId xmlns:r="http://schemas.openxmlformats.org/officeDocument/2006/relationships" id="265" r:id="Rb3e78ee1ce484f78"/>
+    <p:sldId xmlns:r="http://schemas.openxmlformats.org/officeDocument/2006/relationships" id="266" r:id="Ra47fcb80d7384f5e"/>
+    <p:sldId xmlns:r="http://schemas.openxmlformats.org/officeDocument/2006/relationships" id="267" r:id="Rb9a946da18d04647"/>
+    <p:sldId xmlns:r="http://schemas.openxmlformats.org/officeDocument/2006/relationships" id="268" r:id="Rc0c1bf6b781543f1"/>
+    <p:sldId xmlns:r="http://schemas.openxmlformats.org/officeDocument/2006/relationships" id="269" r:id="Rc46b22341afc463f"/>
   </p:sldIdLst>
   <p:sldSz cx="12192000" cy="6858000"/>
   <p:notesSz cx="6858000" cy="9144000"/>
@@ -1472,7 +1472,7 @@
   </p:cSld>
   <p:clrMap bg1="lt1" tx1="dk1" bg2="lt2" tx2="dk2" accent1="accent1" accent2="accent2" accent3="accent3" accent4="accent4" accent5="accent5" accent6="accent6" hlink="hlink" folHlink="folHlink"/>
   <p:sldLayoutIdLst>
-    <p:sldLayoutId xmlns:r="http://schemas.openxmlformats.org/officeDocument/2006/relationships" id="2147483649" r:id="Rd1856857b83f4763"/>
+    <p:sldLayoutId xmlns:r="http://schemas.openxmlformats.org/officeDocument/2006/relationships" id="2147483649" r:id="R16b295aae6574d42"/>
   </p:sldLayoutIdLst>
   <p:txStyles>
     <p:titleStyle>
@@ -2020,21 +2020,21 @@
       </p:grpSpPr>
       <p:pic>
         <p:nvPicPr>
-          <p:cNvPr id="9" name=""/>
+          <p:cNvPr id="10" name=""/>
           <p:cNvPicPr>
             <a:picLocks xmlns:a="http://schemas.openxmlformats.org/drawingml/2006/main" noChangeAspect="1"/>
           </p:cNvPicPr>
           <p:nvPr/>
         </p:nvPicPr>
         <p:blipFill>
-          <a:blip xmlns:r="http://schemas.openxmlformats.org/officeDocument/2006/relationships" xmlns:a="http://schemas.openxmlformats.org/drawingml/2006/main" r:embed="R2d15f4135f5a432a"/>
+          <a:blip xmlns:r="http://schemas.openxmlformats.org/officeDocument/2006/relationships" xmlns:a="http://schemas.openxmlformats.org/drawingml/2006/main" r:embed="R1a933982bf054abe"/>
           <a:srcRect xmlns:a="http://schemas.openxmlformats.org/drawingml/2006/main" l="23166" t="0" r="23166" b="0"/>
           <a:stretch xmlns:a="http://schemas.openxmlformats.org/drawingml/2006/main">
             <a:fillRect l="0" t="0" r="0" b="0"/>
           </a:stretch>
         </p:blipFill>
         <p:spPr>
-          <a:xfrm xmlns:a="http://schemas.openxmlformats.org/drawingml/2006/main">
+          <a:xfrm xmlns:a="http://schemas.openxmlformats.org/drawingml/2006/main" flipH="0" flipV="0">
             <a:off x="6191250" y="514350"/>
             <a:ext cx="5543550" cy="5810250"/>
           </a:xfrm>
@@ -2139,6 +2139,7 @@
           <a:lstStyle xmlns:a="http://schemas.openxmlformats.org/drawingml/2006/main"/>
           <a:p xmlns:a="http://schemas.openxmlformats.org/drawingml/2006/main">
             <a:pPr algn="l">
+              <a:buNone/>
               <a:defRPr sz="1350" b="1">
                 <a:solidFill>
                   <a:srgbClr val="B76043"/>
@@ -2149,7 +2150,7 @@
               </a:defRPr>
             </a:pPr>
             <a:r>
-              <a:t>OUTLOOK SIGNALS</a:t>
+              <a:t>OUTLOOK AI SIGNALS</a:t>
             </a:r>
           </a:p>
         </p:txBody>
@@ -2184,6 +2185,7 @@
           <a:lstStyle xmlns:a="http://schemas.openxmlformats.org/drawingml/2006/main"/>
           <a:p xmlns:a="http://schemas.openxmlformats.org/drawingml/2006/main">
             <a:pPr algn="l">
+              <a:buNone/>
               <a:defRPr sz="4350" b="1">
                 <a:solidFill>
                   <a:srgbClr val="24211D"/>
@@ -2230,6 +2232,7 @@
           <a:lstStyle xmlns:a="http://schemas.openxmlformats.org/drawingml/2006/main"/>
           <a:p xmlns:a="http://schemas.openxmlformats.org/drawingml/2006/main">
             <a:pPr algn="l">
+              <a:buNone/>
               <a:defRPr sz="1800" b="0">
                 <a:solidFill>
                   <a:srgbClr val="716B63"/>
@@ -2311,6 +2314,7 @@
           <a:lstStyle xmlns:a="http://schemas.openxmlformats.org/drawingml/2006/main"/>
           <a:p xmlns:a="http://schemas.openxmlformats.org/drawingml/2006/main">
             <a:pPr algn="ctr">
+              <a:buNone/>
               <a:defRPr sz="1200" b="1">
                 <a:solidFill>
                   <a:srgbClr val="667E95"/>
@@ -2385,6 +2389,7 @@
           <a:lstStyle xmlns:a="http://schemas.openxmlformats.org/drawingml/2006/main"/>
           <a:p xmlns:a="http://schemas.openxmlformats.org/drawingml/2006/main">
             <a:pPr algn="l">
+              <a:buNone/>
               <a:defRPr sz="1125" b="1">
                 <a:solidFill>
                   <a:srgbClr val="B76043"/>
@@ -2395,7 +2400,7 @@
               </a:defRPr>
             </a:pPr>
             <a:r>
-              <a:t>OUTLOOK SIGNALS</a:t>
+              <a:t>OUTLOOK AI SIGNALS</a:t>
             </a:r>
           </a:p>
         </p:txBody>
@@ -2430,6 +2435,7 @@
           <a:lstStyle xmlns:a="http://schemas.openxmlformats.org/drawingml/2006/main"/>
           <a:p xmlns:a="http://schemas.openxmlformats.org/drawingml/2006/main">
             <a:pPr algn="l">
+              <a:buNone/>
               <a:defRPr sz="3150" b="1">
                 <a:solidFill>
                   <a:srgbClr val="24211D"/>
@@ -2447,7 +2453,7 @@
       </p:sp>
       <p:cxnSp>
         <p:nvCxnSpPr>
-          <p:cNvPr id="20" name=""/>
+          <p:cNvPr id="26" name=""/>
           <p:cNvCxnSpPr/>
           <p:nvPr/>
         </p:nvCxnSpPr>
@@ -2497,6 +2503,7 @@
           <a:lstStyle xmlns:a="http://schemas.openxmlformats.org/drawingml/2006/main"/>
           <a:p xmlns:a="http://schemas.openxmlformats.org/drawingml/2006/main">
             <a:pPr algn="r">
+              <a:buNone/>
               <a:defRPr sz="1050" b="0">
                 <a:solidFill>
                   <a:srgbClr val="716B63"/>
@@ -2682,6 +2689,7 @@
           <a:lstStyle xmlns:a="http://schemas.openxmlformats.org/drawingml/2006/main"/>
           <a:p xmlns:a="http://schemas.openxmlformats.org/drawingml/2006/main">
             <a:pPr algn="l">
+              <a:buNone/>
               <a:defRPr sz="1500" b="1">
                 <a:solidFill>
                   <a:srgbClr val="716B63"/>
@@ -2727,6 +2735,7 @@
           <a:lstStyle xmlns:a="http://schemas.openxmlformats.org/drawingml/2006/main"/>
           <a:p xmlns:a="http://schemas.openxmlformats.org/drawingml/2006/main">
             <a:pPr algn="l">
+              <a:buNone/>
               <a:defRPr sz="1500" b="1">
                 <a:solidFill>
                   <a:srgbClr val="667E95"/>
@@ -2772,6 +2781,7 @@
           <a:lstStyle xmlns:a="http://schemas.openxmlformats.org/drawingml/2006/main"/>
           <a:p xmlns:a="http://schemas.openxmlformats.org/drawingml/2006/main">
             <a:pPr algn="l">
+              <a:buNone/>
               <a:defRPr sz="1500" b="1">
                 <a:solidFill>
                   <a:srgbClr val="B76043"/>
@@ -2817,6 +2827,7 @@
           <a:lstStyle xmlns:a="http://schemas.openxmlformats.org/drawingml/2006/main"/>
           <a:p xmlns:a="http://schemas.openxmlformats.org/drawingml/2006/main">
             <a:pPr algn="ctr">
+              <a:buNone/>
               <a:defRPr sz="2025" b="1">
                 <a:solidFill>
                   <a:srgbClr val="FFFFFF"/>
@@ -2862,6 +2873,7 @@
           <a:lstStyle xmlns:a="http://schemas.openxmlformats.org/drawingml/2006/main"/>
           <a:p xmlns:a="http://schemas.openxmlformats.org/drawingml/2006/main">
             <a:pPr algn="l">
+              <a:buNone/>
               <a:defRPr sz="1725" b="1">
                 <a:solidFill>
                   <a:srgbClr val="24211D"/>
@@ -2907,6 +2919,7 @@
           <a:lstStyle xmlns:a="http://schemas.openxmlformats.org/drawingml/2006/main"/>
           <a:p xmlns:a="http://schemas.openxmlformats.org/drawingml/2006/main">
             <a:pPr algn="l">
+              <a:buNone/>
               <a:defRPr sz="1725" b="1">
                 <a:solidFill>
                   <a:srgbClr val="24211D"/>
@@ -2952,6 +2965,7 @@
           <a:lstStyle xmlns:a="http://schemas.openxmlformats.org/drawingml/2006/main"/>
           <a:p xmlns:a="http://schemas.openxmlformats.org/drawingml/2006/main">
             <a:pPr algn="l">
+              <a:buNone/>
               <a:defRPr sz="1725" b="1">
                 <a:solidFill>
                   <a:srgbClr val="24211D"/>
@@ -2997,6 +3011,7 @@
           <a:lstStyle xmlns:a="http://schemas.openxmlformats.org/drawingml/2006/main"/>
           <a:p xmlns:a="http://schemas.openxmlformats.org/drawingml/2006/main">
             <a:pPr algn="l">
+              <a:buNone/>
               <a:defRPr sz="1725" b="1">
                 <a:solidFill>
                   <a:srgbClr val="24211D"/>
@@ -3042,6 +3057,7 @@
           <a:lstStyle xmlns:a="http://schemas.openxmlformats.org/drawingml/2006/main"/>
           <a:p xmlns:a="http://schemas.openxmlformats.org/drawingml/2006/main">
             <a:pPr algn="ctr">
+              <a:buNone/>
               <a:defRPr sz="1650" b="1">
                 <a:solidFill>
                   <a:srgbClr val="B76043"/>
@@ -3116,6 +3132,7 @@
           <a:lstStyle xmlns:a="http://schemas.openxmlformats.org/drawingml/2006/main"/>
           <a:p xmlns:a="http://schemas.openxmlformats.org/drawingml/2006/main">
             <a:pPr algn="l">
+              <a:buNone/>
               <a:defRPr sz="1125" b="1">
                 <a:solidFill>
                   <a:srgbClr val="B76043"/>
@@ -3126,7 +3143,7 @@
               </a:defRPr>
             </a:pPr>
             <a:r>
-              <a:t>OUTLOOK SIGNALS</a:t>
+              <a:t>OUTLOOK AI SIGNALS</a:t>
             </a:r>
           </a:p>
         </p:txBody>
@@ -3161,6 +3178,7 @@
           <a:lstStyle xmlns:a="http://schemas.openxmlformats.org/drawingml/2006/main"/>
           <a:p xmlns:a="http://schemas.openxmlformats.org/drawingml/2006/main">
             <a:pPr algn="l">
+              <a:buNone/>
               <a:defRPr sz="3150" b="1">
                 <a:solidFill>
                   <a:srgbClr val="24211D"/>
@@ -3178,7 +3196,7 @@
       </p:sp>
       <p:cxnSp>
         <p:nvCxnSpPr>
-          <p:cNvPr id="27" name=""/>
+          <p:cNvPr id="47" name=""/>
           <p:cNvCxnSpPr/>
           <p:nvPr/>
         </p:nvCxnSpPr>
@@ -3228,6 +3246,7 @@
           <a:lstStyle xmlns:a="http://schemas.openxmlformats.org/drawingml/2006/main"/>
           <a:p xmlns:a="http://schemas.openxmlformats.org/drawingml/2006/main">
             <a:pPr algn="r">
+              <a:buNone/>
               <a:defRPr sz="1050" b="0">
                 <a:solidFill>
                   <a:srgbClr val="716B63"/>
@@ -3245,7 +3264,7 @@
       </p:sp>
       <p:cxnSp>
         <p:nvCxnSpPr>
-          <p:cNvPr id="29" name=""/>
+          <p:cNvPr id="49" name=""/>
           <p:cNvCxnSpPr/>
           <p:nvPr/>
         </p:nvCxnSpPr>
@@ -3267,7 +3286,7 @@
       </p:cxnSp>
       <p:cxnSp>
         <p:nvCxnSpPr>
-          <p:cNvPr id="30" name=""/>
+          <p:cNvPr id="50" name=""/>
           <p:cNvCxnSpPr/>
           <p:nvPr/>
         </p:nvCxnSpPr>
@@ -3289,7 +3308,7 @@
       </p:cxnSp>
       <p:cxnSp>
         <p:nvCxnSpPr>
-          <p:cNvPr id="31" name=""/>
+          <p:cNvPr id="51" name=""/>
           <p:cNvCxnSpPr/>
           <p:nvPr/>
         </p:nvCxnSpPr>
@@ -3311,7 +3330,7 @@
       </p:cxnSp>
       <p:cxnSp>
         <p:nvCxnSpPr>
-          <p:cNvPr id="32" name=""/>
+          <p:cNvPr id="52" name=""/>
           <p:cNvCxnSpPr/>
           <p:nvPr/>
         </p:nvCxnSpPr>
@@ -3333,7 +3352,7 @@
       </p:cxnSp>
       <p:cxnSp>
         <p:nvCxnSpPr>
-          <p:cNvPr id="33" name=""/>
+          <p:cNvPr id="53" name=""/>
           <p:cNvCxnSpPr/>
           <p:nvPr/>
         </p:nvCxnSpPr>
@@ -3355,7 +3374,7 @@
       </p:cxnSp>
       <p:cxnSp>
         <p:nvCxnSpPr>
-          <p:cNvPr id="34" name=""/>
+          <p:cNvPr id="54" name=""/>
           <p:cNvCxnSpPr/>
           <p:nvPr/>
         </p:nvCxnSpPr>
@@ -3615,6 +3634,7 @@
           <a:lstStyle xmlns:a="http://schemas.openxmlformats.org/drawingml/2006/main"/>
           <a:p xmlns:a="http://schemas.openxmlformats.org/drawingml/2006/main">
             <a:pPr algn="ctr">
+              <a:buNone/>
               <a:defRPr sz="1725" b="1">
                 <a:solidFill>
                   <a:srgbClr val="24211D"/>
@@ -3660,6 +3680,7 @@
           <a:lstStyle xmlns:a="http://schemas.openxmlformats.org/drawingml/2006/main"/>
           <a:p xmlns:a="http://schemas.openxmlformats.org/drawingml/2006/main">
             <a:pPr algn="ctr">
+              <a:buNone/>
               <a:defRPr sz="1650" b="1">
                 <a:solidFill>
                   <a:srgbClr val="24211D"/>
@@ -3706,6 +3727,7 @@
           <a:lstStyle xmlns:a="http://schemas.openxmlformats.org/drawingml/2006/main"/>
           <a:p xmlns:a="http://schemas.openxmlformats.org/drawingml/2006/main">
             <a:pPr algn="ctr">
+              <a:buNone/>
               <a:defRPr sz="1650" b="1">
                 <a:solidFill>
                   <a:srgbClr val="24211D"/>
@@ -3751,6 +3773,7 @@
           <a:lstStyle xmlns:a="http://schemas.openxmlformats.org/drawingml/2006/main"/>
           <a:p xmlns:a="http://schemas.openxmlformats.org/drawingml/2006/main">
             <a:pPr algn="ctr">
+              <a:buNone/>
               <a:defRPr sz="1650" b="1">
                 <a:solidFill>
                   <a:srgbClr val="24211D"/>
@@ -3796,6 +3819,7 @@
           <a:lstStyle xmlns:a="http://schemas.openxmlformats.org/drawingml/2006/main"/>
           <a:p xmlns:a="http://schemas.openxmlformats.org/drawingml/2006/main">
             <a:pPr algn="ctr">
+              <a:buNone/>
               <a:defRPr sz="1650" b="1">
                 <a:solidFill>
                   <a:srgbClr val="24211D"/>
@@ -3841,6 +3865,7 @@
           <a:lstStyle xmlns:a="http://schemas.openxmlformats.org/drawingml/2006/main"/>
           <a:p xmlns:a="http://schemas.openxmlformats.org/drawingml/2006/main">
             <a:pPr algn="ctr">
+              <a:buNone/>
               <a:defRPr sz="1650" b="1">
                 <a:solidFill>
                   <a:srgbClr val="B76043"/>
@@ -3886,6 +3911,7 @@
           <a:lstStyle xmlns:a="http://schemas.openxmlformats.org/drawingml/2006/main"/>
           <a:p xmlns:a="http://schemas.openxmlformats.org/drawingml/2006/main">
             <a:pPr algn="ctr">
+              <a:buNone/>
               <a:defRPr sz="1500" b="1">
                 <a:solidFill>
                   <a:srgbClr val="667E95"/>
@@ -3931,6 +3957,7 @@
           <a:lstStyle xmlns:a="http://schemas.openxmlformats.org/drawingml/2006/main"/>
           <a:p xmlns:a="http://schemas.openxmlformats.org/drawingml/2006/main">
             <a:pPr algn="ctr">
+              <a:buNone/>
               <a:defRPr sz="1500" b="1">
                 <a:solidFill>
                   <a:srgbClr val="B76043"/>
@@ -4005,6 +4032,7 @@
           <a:lstStyle xmlns:a="http://schemas.openxmlformats.org/drawingml/2006/main"/>
           <a:p xmlns:a="http://schemas.openxmlformats.org/drawingml/2006/main">
             <a:pPr algn="l">
+              <a:buNone/>
               <a:defRPr sz="1125" b="1">
                 <a:solidFill>
                   <a:srgbClr val="B76043"/>
@@ -4015,7 +4043,7 @@
               </a:defRPr>
             </a:pPr>
             <a:r>
-              <a:t>OUTLOOK SIGNALS</a:t>
+              <a:t>OUTLOOK AI SIGNALS</a:t>
             </a:r>
           </a:p>
         </p:txBody>
@@ -4050,6 +4078,7 @@
           <a:lstStyle xmlns:a="http://schemas.openxmlformats.org/drawingml/2006/main"/>
           <a:p xmlns:a="http://schemas.openxmlformats.org/drawingml/2006/main">
             <a:pPr algn="l">
+              <a:buNone/>
               <a:defRPr sz="3150" b="1">
                 <a:solidFill>
                   <a:srgbClr val="24211D"/>
@@ -4067,7 +4096,7 @@
       </p:sp>
       <p:cxnSp>
         <p:nvCxnSpPr>
-          <p:cNvPr id="31" name=""/>
+          <p:cNvPr id="45" name=""/>
           <p:cNvCxnSpPr/>
           <p:nvPr/>
         </p:nvCxnSpPr>
@@ -4117,6 +4146,7 @@
           <a:lstStyle xmlns:a="http://schemas.openxmlformats.org/drawingml/2006/main"/>
           <a:p xmlns:a="http://schemas.openxmlformats.org/drawingml/2006/main">
             <a:pPr algn="r">
+              <a:buNone/>
               <a:defRPr sz="1050" b="0">
                 <a:solidFill>
                   <a:srgbClr val="716B63"/>
@@ -4134,7 +4164,7 @@
       </p:sp>
       <p:cxnSp>
         <p:nvCxnSpPr>
-          <p:cNvPr id="33" name=""/>
+          <p:cNvPr id="47" name=""/>
           <p:cNvCxnSpPr/>
           <p:nvPr/>
         </p:nvCxnSpPr>
@@ -4156,7 +4186,7 @@
       </p:cxnSp>
       <p:cxnSp>
         <p:nvCxnSpPr>
-          <p:cNvPr id="34" name=""/>
+          <p:cNvPr id="48" name=""/>
           <p:cNvCxnSpPr/>
           <p:nvPr/>
         </p:nvCxnSpPr>
@@ -4178,7 +4208,7 @@
       </p:cxnSp>
       <p:cxnSp>
         <p:nvCxnSpPr>
-          <p:cNvPr id="35" name=""/>
+          <p:cNvPr id="49" name=""/>
           <p:cNvCxnSpPr/>
           <p:nvPr/>
         </p:nvCxnSpPr>
@@ -4368,6 +4398,7 @@
           <a:lstStyle xmlns:a="http://schemas.openxmlformats.org/drawingml/2006/main"/>
           <a:p xmlns:a="http://schemas.openxmlformats.org/drawingml/2006/main">
             <a:pPr algn="l">
+              <a:buNone/>
               <a:defRPr sz="1950" b="1">
                 <a:solidFill>
                   <a:srgbClr val="B76043"/>
@@ -4413,6 +4444,7 @@
           <a:lstStyle xmlns:a="http://schemas.openxmlformats.org/drawingml/2006/main"/>
           <a:p xmlns:a="http://schemas.openxmlformats.org/drawingml/2006/main">
             <a:pPr algn="l">
+              <a:buNone/>
               <a:defRPr sz="1575" b="1">
                 <a:solidFill>
                   <a:srgbClr val="24211D"/>
@@ -4458,6 +4490,7 @@
           <a:lstStyle xmlns:a="http://schemas.openxmlformats.org/drawingml/2006/main"/>
           <a:p xmlns:a="http://schemas.openxmlformats.org/drawingml/2006/main">
             <a:pPr algn="l">
+              <a:buNone/>
               <a:defRPr sz="1500" b="0">
                 <a:solidFill>
                   <a:srgbClr val="716B63"/>
@@ -4503,6 +4536,7 @@
           <a:lstStyle xmlns:a="http://schemas.openxmlformats.org/drawingml/2006/main"/>
           <a:p xmlns:a="http://schemas.openxmlformats.org/drawingml/2006/main">
             <a:pPr algn="l">
+              <a:buNone/>
               <a:defRPr sz="1500" b="0">
                 <a:solidFill>
                   <a:srgbClr val="716B63"/>
@@ -4552,6 +4586,7 @@
           <a:lstStyle xmlns:a="http://schemas.openxmlformats.org/drawingml/2006/main"/>
           <a:p xmlns:a="http://schemas.openxmlformats.org/drawingml/2006/main">
             <a:pPr algn="ctr">
+              <a:buNone/>
               <a:defRPr sz="1800" b="1">
                 <a:solidFill>
                   <a:srgbClr val="B76043"/>
@@ -4597,6 +4632,7 @@
           <a:lstStyle xmlns:a="http://schemas.openxmlformats.org/drawingml/2006/main"/>
           <a:p xmlns:a="http://schemas.openxmlformats.org/drawingml/2006/main">
             <a:pPr algn="ctr">
+              <a:buNone/>
               <a:defRPr sz="1350" b="1">
                 <a:solidFill>
                   <a:srgbClr val="24211D"/>
@@ -4642,6 +4678,7 @@
           <a:lstStyle xmlns:a="http://schemas.openxmlformats.org/drawingml/2006/main"/>
           <a:p xmlns:a="http://schemas.openxmlformats.org/drawingml/2006/main">
             <a:pPr algn="ctr">
+              <a:buNone/>
               <a:defRPr sz="1350" b="0">
                 <a:solidFill>
                   <a:srgbClr val="716B63"/>
@@ -4687,6 +4724,7 @@
           <a:lstStyle xmlns:a="http://schemas.openxmlformats.org/drawingml/2006/main"/>
           <a:p xmlns:a="http://schemas.openxmlformats.org/drawingml/2006/main">
             <a:pPr algn="ctr">
+              <a:buNone/>
               <a:defRPr sz="1425" b="0">
                 <a:solidFill>
                   <a:srgbClr val="716B63"/>
@@ -4734,6 +4772,7 @@
           <a:lstStyle xmlns:a="http://schemas.openxmlformats.org/drawingml/2006/main"/>
           <a:p xmlns:a="http://schemas.openxmlformats.org/drawingml/2006/main">
             <a:pPr algn="ctr">
+              <a:buNone/>
               <a:defRPr sz="1800" b="1">
                 <a:solidFill>
                   <a:srgbClr val="667E95"/>
@@ -4779,6 +4818,7 @@
           <a:lstStyle xmlns:a="http://schemas.openxmlformats.org/drawingml/2006/main"/>
           <a:p xmlns:a="http://schemas.openxmlformats.org/drawingml/2006/main">
             <a:pPr algn="ctr">
+              <a:buNone/>
               <a:defRPr sz="1350" b="1">
                 <a:solidFill>
                   <a:srgbClr val="24211D"/>
@@ -4824,6 +4864,7 @@
           <a:lstStyle xmlns:a="http://schemas.openxmlformats.org/drawingml/2006/main"/>
           <a:p xmlns:a="http://schemas.openxmlformats.org/drawingml/2006/main">
             <a:pPr algn="ctr">
+              <a:buNone/>
               <a:defRPr sz="1350" b="0">
                 <a:solidFill>
                   <a:srgbClr val="716B63"/>
@@ -4869,6 +4910,7 @@
           <a:lstStyle xmlns:a="http://schemas.openxmlformats.org/drawingml/2006/main"/>
           <a:p xmlns:a="http://schemas.openxmlformats.org/drawingml/2006/main">
             <a:pPr algn="ctr">
+              <a:buNone/>
               <a:defRPr sz="1425" b="0">
                 <a:solidFill>
                   <a:srgbClr val="716B63"/>
@@ -4916,6 +4958,7 @@
           <a:lstStyle xmlns:a="http://schemas.openxmlformats.org/drawingml/2006/main"/>
           <a:p xmlns:a="http://schemas.openxmlformats.org/drawingml/2006/main">
             <a:pPr algn="ctr">
+              <a:buNone/>
               <a:defRPr sz="1800" b="1">
                 <a:solidFill>
                   <a:srgbClr val="B76043"/>
@@ -4961,6 +5004,7 @@
           <a:lstStyle xmlns:a="http://schemas.openxmlformats.org/drawingml/2006/main"/>
           <a:p xmlns:a="http://schemas.openxmlformats.org/drawingml/2006/main">
             <a:pPr algn="ctr">
+              <a:buNone/>
               <a:defRPr sz="1350" b="1">
                 <a:solidFill>
                   <a:srgbClr val="24211D"/>
@@ -5006,6 +5050,7 @@
           <a:lstStyle xmlns:a="http://schemas.openxmlformats.org/drawingml/2006/main"/>
           <a:p xmlns:a="http://schemas.openxmlformats.org/drawingml/2006/main">
             <a:pPr algn="ctr">
+              <a:buNone/>
               <a:defRPr sz="1350" b="0">
                 <a:solidFill>
                   <a:srgbClr val="716B63"/>
@@ -5051,6 +5096,7 @@
           <a:lstStyle xmlns:a="http://schemas.openxmlformats.org/drawingml/2006/main"/>
           <a:p xmlns:a="http://schemas.openxmlformats.org/drawingml/2006/main">
             <a:pPr algn="ctr">
+              <a:buNone/>
               <a:defRPr sz="1425" b="0">
                 <a:solidFill>
                   <a:srgbClr val="716B63"/>
@@ -5098,6 +5144,7 @@
           <a:lstStyle xmlns:a="http://schemas.openxmlformats.org/drawingml/2006/main"/>
           <a:p xmlns:a="http://schemas.openxmlformats.org/drawingml/2006/main">
             <a:pPr algn="ctr">
+              <a:buNone/>
               <a:defRPr sz="1650" b="1">
                 <a:solidFill>
                   <a:srgbClr val="B76043"/>
@@ -5172,6 +5219,7 @@
           <a:lstStyle xmlns:a="http://schemas.openxmlformats.org/drawingml/2006/main"/>
           <a:p xmlns:a="http://schemas.openxmlformats.org/drawingml/2006/main">
             <a:pPr algn="l">
+              <a:buNone/>
               <a:defRPr sz="1125" b="1">
                 <a:solidFill>
                   <a:srgbClr val="B76043"/>
@@ -5182,7 +5230,7 @@
               </a:defRPr>
             </a:pPr>
             <a:r>
-              <a:t>OUTLOOK SIGNALS</a:t>
+              <a:t>OUTLOOK AI SIGNALS</a:t>
             </a:r>
           </a:p>
         </p:txBody>
@@ -5217,6 +5265,7 @@
           <a:lstStyle xmlns:a="http://schemas.openxmlformats.org/drawingml/2006/main"/>
           <a:p xmlns:a="http://schemas.openxmlformats.org/drawingml/2006/main">
             <a:pPr algn="l">
+              <a:buNone/>
               <a:defRPr sz="3150" b="1">
                 <a:solidFill>
                   <a:srgbClr val="24211D"/>
@@ -5234,7 +5283,7 @@
       </p:sp>
       <p:cxnSp>
         <p:nvCxnSpPr>
-          <p:cNvPr id="21" name=""/>
+          <p:cNvPr id="27" name=""/>
           <p:cNvCxnSpPr/>
           <p:nvPr/>
         </p:nvCxnSpPr>
@@ -5284,6 +5333,7 @@
           <a:lstStyle xmlns:a="http://schemas.openxmlformats.org/drawingml/2006/main"/>
           <a:p xmlns:a="http://schemas.openxmlformats.org/drawingml/2006/main">
             <a:pPr algn="r">
+              <a:buNone/>
               <a:defRPr sz="1050" b="0">
                 <a:solidFill>
                   <a:srgbClr val="716B63"/>
@@ -5329,6 +5379,7 @@
           <a:lstStyle xmlns:a="http://schemas.openxmlformats.org/drawingml/2006/main"/>
           <a:p xmlns:a="http://schemas.openxmlformats.org/drawingml/2006/main">
             <a:pPr algn="ctr">
+              <a:buNone/>
               <a:defRPr sz="1725" b="0">
                 <a:solidFill>
                   <a:srgbClr val="716B63"/>
@@ -5409,6 +5460,7 @@
           <a:lstStyle xmlns:a="http://schemas.openxmlformats.org/drawingml/2006/main"/>
           <a:p xmlns:a="http://schemas.openxmlformats.org/drawingml/2006/main">
             <a:pPr algn="l">
+              <a:buNone/>
               <a:defRPr sz="4050" b="1">
                 <a:solidFill>
                   <a:srgbClr val="B76043"/>
@@ -5454,6 +5506,7 @@
           <a:lstStyle xmlns:a="http://schemas.openxmlformats.org/drawingml/2006/main"/>
           <a:p xmlns:a="http://schemas.openxmlformats.org/drawingml/2006/main">
             <a:pPr algn="l">
+              <a:buNone/>
               <a:defRPr sz="1650" b="1">
                 <a:solidFill>
                   <a:srgbClr val="24211D"/>
@@ -5499,6 +5552,7 @@
           <a:lstStyle xmlns:a="http://schemas.openxmlformats.org/drawingml/2006/main"/>
           <a:p xmlns:a="http://schemas.openxmlformats.org/drawingml/2006/main">
             <a:pPr algn="l">
+              <a:buNone/>
               <a:defRPr sz="1350" b="0">
                 <a:solidFill>
                   <a:srgbClr val="716B63"/>
@@ -5579,6 +5633,7 @@
           <a:lstStyle xmlns:a="http://schemas.openxmlformats.org/drawingml/2006/main"/>
           <a:p xmlns:a="http://schemas.openxmlformats.org/drawingml/2006/main">
             <a:pPr algn="l">
+              <a:buNone/>
               <a:defRPr sz="4050" b="1">
                 <a:solidFill>
                   <a:srgbClr val="667E95"/>
@@ -5624,6 +5679,7 @@
           <a:lstStyle xmlns:a="http://schemas.openxmlformats.org/drawingml/2006/main"/>
           <a:p xmlns:a="http://schemas.openxmlformats.org/drawingml/2006/main">
             <a:pPr algn="l">
+              <a:buNone/>
               <a:defRPr sz="1650" b="1">
                 <a:solidFill>
                   <a:srgbClr val="24211D"/>
@@ -5669,6 +5725,7 @@
           <a:lstStyle xmlns:a="http://schemas.openxmlformats.org/drawingml/2006/main"/>
           <a:p xmlns:a="http://schemas.openxmlformats.org/drawingml/2006/main">
             <a:pPr algn="l">
+              <a:buNone/>
               <a:defRPr sz="1350" b="0">
                 <a:solidFill>
                   <a:srgbClr val="716B63"/>
@@ -5749,6 +5806,7 @@
           <a:lstStyle xmlns:a="http://schemas.openxmlformats.org/drawingml/2006/main"/>
           <a:p xmlns:a="http://schemas.openxmlformats.org/drawingml/2006/main">
             <a:pPr algn="l">
+              <a:buNone/>
               <a:defRPr sz="4050" b="1">
                 <a:solidFill>
                   <a:srgbClr val="B76043"/>
@@ -5794,6 +5852,7 @@
           <a:lstStyle xmlns:a="http://schemas.openxmlformats.org/drawingml/2006/main"/>
           <a:p xmlns:a="http://schemas.openxmlformats.org/drawingml/2006/main">
             <a:pPr algn="l">
+              <a:buNone/>
               <a:defRPr sz="1650" b="1">
                 <a:solidFill>
                   <a:srgbClr val="24211D"/>
@@ -5839,6 +5898,7 @@
           <a:lstStyle xmlns:a="http://schemas.openxmlformats.org/drawingml/2006/main"/>
           <a:p xmlns:a="http://schemas.openxmlformats.org/drawingml/2006/main">
             <a:pPr algn="l">
+              <a:buNone/>
               <a:defRPr sz="1350" b="0">
                 <a:solidFill>
                   <a:srgbClr val="716B63"/>
@@ -5884,6 +5944,7 @@
           <a:lstStyle xmlns:a="http://schemas.openxmlformats.org/drawingml/2006/main"/>
           <a:p xmlns:a="http://schemas.openxmlformats.org/drawingml/2006/main">
             <a:pPr algn="ctr">
+              <a:buNone/>
               <a:defRPr sz="1500" b="1">
                 <a:solidFill>
                   <a:srgbClr val="B76043"/>
@@ -5958,6 +6019,7 @@
           <a:lstStyle xmlns:a="http://schemas.openxmlformats.org/drawingml/2006/main"/>
           <a:p xmlns:a="http://schemas.openxmlformats.org/drawingml/2006/main">
             <a:pPr algn="l">
+              <a:buNone/>
               <a:defRPr sz="1350" b="1">
                 <a:solidFill>
                   <a:srgbClr val="F1DDD3"/>
@@ -5968,7 +6030,7 @@
               </a:defRPr>
             </a:pPr>
             <a:r>
-              <a:t>OUTLOOK SIGNALS</a:t>
+              <a:t>OUTLOOK AI SIGNALS</a:t>
             </a:r>
           </a:p>
         </p:txBody>
@@ -6003,6 +6065,7 @@
           <a:lstStyle xmlns:a="http://schemas.openxmlformats.org/drawingml/2006/main"/>
           <a:p xmlns:a="http://schemas.openxmlformats.org/drawingml/2006/main">
             <a:pPr algn="ctr">
+              <a:buNone/>
               <a:defRPr sz="4050" b="1">
                 <a:solidFill>
                   <a:srgbClr val="FFFFFF"/>
@@ -6021,7 +6084,7 @@
       </p:sp>
       <p:cxnSp>
         <p:nvCxnSpPr>
-          <p:cNvPr id="13" name=""/>
+          <p:cNvPr id="19" name=""/>
           <p:cNvCxnSpPr/>
           <p:nvPr/>
         </p:nvCxnSpPr>
@@ -6170,6 +6233,7 @@
           <a:lstStyle xmlns:a="http://schemas.openxmlformats.org/drawingml/2006/main"/>
           <a:p xmlns:a="http://schemas.openxmlformats.org/drawingml/2006/main">
             <a:pPr algn="ctr">
+              <a:buNone/>
               <a:defRPr sz="1650" b="1">
                 <a:solidFill>
                   <a:srgbClr val="FFFFFF"/>
@@ -6215,6 +6279,7 @@
           <a:lstStyle xmlns:a="http://schemas.openxmlformats.org/drawingml/2006/main"/>
           <a:p xmlns:a="http://schemas.openxmlformats.org/drawingml/2006/main">
             <a:pPr algn="ctr">
+              <a:buNone/>
               <a:defRPr sz="1650" b="1">
                 <a:solidFill>
                   <a:srgbClr val="FFFFFF"/>
@@ -6260,6 +6325,7 @@
           <a:lstStyle xmlns:a="http://schemas.openxmlformats.org/drawingml/2006/main"/>
           <a:p xmlns:a="http://schemas.openxmlformats.org/drawingml/2006/main">
             <a:pPr algn="ctr">
+              <a:buNone/>
               <a:defRPr sz="1650" b="1">
                 <a:solidFill>
                   <a:srgbClr val="FFFFFF"/>
@@ -6305,6 +6371,7 @@
           <a:lstStyle xmlns:a="http://schemas.openxmlformats.org/drawingml/2006/main"/>
           <a:p xmlns:a="http://schemas.openxmlformats.org/drawingml/2006/main">
             <a:pPr algn="ctr">
+              <a:buNone/>
               <a:defRPr sz="1800" b="0">
                 <a:solidFill>
                   <a:srgbClr val="F1DDD3"/>
@@ -6379,6 +6446,7 @@
           <a:lstStyle xmlns:a="http://schemas.openxmlformats.org/drawingml/2006/main"/>
           <a:p xmlns:a="http://schemas.openxmlformats.org/drawingml/2006/main">
             <a:pPr algn="l">
+              <a:buNone/>
               <a:defRPr sz="1125" b="1">
                 <a:solidFill>
                   <a:srgbClr val="B76043"/>
@@ -6389,7 +6457,7 @@
               </a:defRPr>
             </a:pPr>
             <a:r>
-              <a:t>OUTLOOK SIGNALS</a:t>
+              <a:t>OUTLOOK AI SIGNALS</a:t>
             </a:r>
           </a:p>
         </p:txBody>
@@ -6424,6 +6492,7 @@
           <a:lstStyle xmlns:a="http://schemas.openxmlformats.org/drawingml/2006/main"/>
           <a:p xmlns:a="http://schemas.openxmlformats.org/drawingml/2006/main">
             <a:pPr algn="l">
+              <a:buNone/>
               <a:defRPr sz="3150" b="1">
                 <a:solidFill>
                   <a:srgbClr val="24211D"/>
@@ -6441,7 +6510,7 @@
       </p:sp>
       <p:cxnSp>
         <p:nvCxnSpPr>
-          <p:cNvPr id="20" name=""/>
+          <p:cNvPr id="26" name=""/>
           <p:cNvCxnSpPr/>
           <p:nvPr/>
         </p:nvCxnSpPr>
@@ -6491,6 +6560,7 @@
           <a:lstStyle xmlns:a="http://schemas.openxmlformats.org/drawingml/2006/main"/>
           <a:p xmlns:a="http://schemas.openxmlformats.org/drawingml/2006/main">
             <a:pPr algn="r">
+              <a:buNone/>
               <a:defRPr sz="1050" b="0">
                 <a:solidFill>
                   <a:srgbClr val="716B63"/>
@@ -6571,6 +6641,7 @@
           <a:lstStyle xmlns:a="http://schemas.openxmlformats.org/drawingml/2006/main"/>
           <a:p xmlns:a="http://schemas.openxmlformats.org/drawingml/2006/main">
             <a:pPr algn="l">
+              <a:buNone/>
               <a:defRPr sz="1500" b="1">
                 <a:solidFill>
                   <a:srgbClr val="B76043"/>
@@ -6616,6 +6687,7 @@
           <a:lstStyle xmlns:a="http://schemas.openxmlformats.org/drawingml/2006/main"/>
           <a:p xmlns:a="http://schemas.openxmlformats.org/drawingml/2006/main">
             <a:pPr algn="l">
+              <a:buNone/>
               <a:defRPr sz="2250" b="1">
                 <a:solidFill>
                   <a:srgbClr val="24211D"/>
@@ -6661,6 +6733,7 @@
           <a:lstStyle xmlns:a="http://schemas.openxmlformats.org/drawingml/2006/main"/>
           <a:p xmlns:a="http://schemas.openxmlformats.org/drawingml/2006/main">
             <a:pPr algn="l">
+              <a:buNone/>
               <a:defRPr sz="1500" b="0">
                 <a:solidFill>
                   <a:srgbClr val="716B63"/>
@@ -6742,6 +6815,7 @@
           <a:lstStyle xmlns:a="http://schemas.openxmlformats.org/drawingml/2006/main"/>
           <a:p xmlns:a="http://schemas.openxmlformats.org/drawingml/2006/main">
             <a:pPr algn="l">
+              <a:buNone/>
               <a:defRPr sz="1500" b="1">
                 <a:solidFill>
                   <a:srgbClr val="667E95"/>
@@ -6787,6 +6861,7 @@
           <a:lstStyle xmlns:a="http://schemas.openxmlformats.org/drawingml/2006/main"/>
           <a:p xmlns:a="http://schemas.openxmlformats.org/drawingml/2006/main">
             <a:pPr algn="l">
+              <a:buNone/>
               <a:defRPr sz="2250" b="1">
                 <a:solidFill>
                   <a:srgbClr val="24211D"/>
@@ -6832,6 +6907,7 @@
           <a:lstStyle xmlns:a="http://schemas.openxmlformats.org/drawingml/2006/main"/>
           <a:p xmlns:a="http://schemas.openxmlformats.org/drawingml/2006/main">
             <a:pPr algn="l">
+              <a:buNone/>
               <a:defRPr sz="1500" b="0">
                 <a:solidFill>
                   <a:srgbClr val="716B63"/>
@@ -6913,6 +6989,7 @@
           <a:lstStyle xmlns:a="http://schemas.openxmlformats.org/drawingml/2006/main"/>
           <a:p xmlns:a="http://schemas.openxmlformats.org/drawingml/2006/main">
             <a:pPr algn="l">
+              <a:buNone/>
               <a:defRPr sz="1500" b="1">
                 <a:solidFill>
                   <a:srgbClr val="B76043"/>
@@ -6958,6 +7035,7 @@
           <a:lstStyle xmlns:a="http://schemas.openxmlformats.org/drawingml/2006/main"/>
           <a:p xmlns:a="http://schemas.openxmlformats.org/drawingml/2006/main">
             <a:pPr algn="l">
+              <a:buNone/>
               <a:defRPr sz="2250" b="1">
                 <a:solidFill>
                   <a:srgbClr val="24211D"/>
@@ -7003,6 +7081,7 @@
           <a:lstStyle xmlns:a="http://schemas.openxmlformats.org/drawingml/2006/main"/>
           <a:p xmlns:a="http://schemas.openxmlformats.org/drawingml/2006/main">
             <a:pPr algn="l">
+              <a:buNone/>
               <a:defRPr sz="1500" b="0">
                 <a:solidFill>
                   <a:srgbClr val="716B63"/>
@@ -7049,6 +7128,7 @@
           <a:lstStyle xmlns:a="http://schemas.openxmlformats.org/drawingml/2006/main"/>
           <a:p xmlns:a="http://schemas.openxmlformats.org/drawingml/2006/main">
             <a:pPr algn="ctr">
+              <a:buNone/>
               <a:defRPr sz="2025" b="1">
                 <a:solidFill>
                   <a:srgbClr val="24211D"/>
@@ -7123,6 +7203,7 @@
           <a:lstStyle xmlns:a="http://schemas.openxmlformats.org/drawingml/2006/main"/>
           <a:p xmlns:a="http://schemas.openxmlformats.org/drawingml/2006/main">
             <a:pPr algn="l">
+              <a:buNone/>
               <a:defRPr sz="1125" b="1">
                 <a:solidFill>
                   <a:srgbClr val="B76043"/>
@@ -7133,7 +7214,7 @@
               </a:defRPr>
             </a:pPr>
             <a:r>
-              <a:t>OUTLOOK SIGNALS</a:t>
+              <a:t>OUTLOOK AI SIGNALS</a:t>
             </a:r>
           </a:p>
         </p:txBody>
@@ -7168,6 +7249,7 @@
           <a:lstStyle xmlns:a="http://schemas.openxmlformats.org/drawingml/2006/main"/>
           <a:p xmlns:a="http://schemas.openxmlformats.org/drawingml/2006/main">
             <a:pPr algn="l">
+              <a:buNone/>
               <a:defRPr sz="3150" b="1">
                 <a:solidFill>
                   <a:srgbClr val="24211D"/>
@@ -7185,7 +7267,7 @@
       </p:sp>
       <p:cxnSp>
         <p:nvCxnSpPr>
-          <p:cNvPr id="25" name=""/>
+          <p:cNvPr id="61" name=""/>
           <p:cNvCxnSpPr/>
           <p:nvPr/>
         </p:nvCxnSpPr>
@@ -7235,6 +7317,7 @@
           <a:lstStyle xmlns:a="http://schemas.openxmlformats.org/drawingml/2006/main"/>
           <a:p xmlns:a="http://schemas.openxmlformats.org/drawingml/2006/main">
             <a:pPr algn="r">
+              <a:buNone/>
               <a:defRPr sz="1050" b="0">
                 <a:solidFill>
                   <a:srgbClr val="716B63"/>
@@ -7280,6 +7363,7 @@
           <a:lstStyle xmlns:a="http://schemas.openxmlformats.org/drawingml/2006/main"/>
           <a:p xmlns:a="http://schemas.openxmlformats.org/drawingml/2006/main">
             <a:pPr algn="l">
+              <a:buNone/>
               <a:defRPr sz="1650" b="1">
                 <a:solidFill>
                   <a:srgbClr val="716B63"/>
@@ -7325,6 +7409,7 @@
           <a:lstStyle xmlns:a="http://schemas.openxmlformats.org/drawingml/2006/main"/>
           <a:p xmlns:a="http://schemas.openxmlformats.org/drawingml/2006/main">
             <a:pPr algn="l">
+              <a:buNone/>
               <a:defRPr sz="2100" b="1">
                 <a:solidFill>
                   <a:srgbClr val="24211D"/>
@@ -7345,7 +7430,7 @@
       </p:sp>
       <p:cxnSp>
         <p:nvCxnSpPr>
-          <p:cNvPr id="29" name=""/>
+          <p:cNvPr id="65" name=""/>
           <p:cNvCxnSpPr/>
           <p:nvPr/>
         </p:nvCxnSpPr>
@@ -7428,6 +7513,7 @@
           <a:lstStyle xmlns:a="http://schemas.openxmlformats.org/drawingml/2006/main"/>
           <a:p xmlns:a="http://schemas.openxmlformats.org/drawingml/2006/main">
             <a:pPr algn="l">
+              <a:buNone/>
               <a:defRPr sz="1650" b="1">
                 <a:solidFill>
                   <a:srgbClr val="716B63"/>
@@ -7445,7 +7531,7 @@
       </p:sp>
       <p:cxnSp>
         <p:nvCxnSpPr>
-          <p:cNvPr id="32" name=""/>
+          <p:cNvPr id="68" name=""/>
           <p:cNvCxnSpPr/>
           <p:nvPr/>
         </p:nvCxnSpPr>
@@ -7467,7 +7553,7 @@
       </p:cxnSp>
       <p:cxnSp>
         <p:nvCxnSpPr>
-          <p:cNvPr id="33" name=""/>
+          <p:cNvPr id="69" name=""/>
           <p:cNvCxnSpPr/>
           <p:nvPr/>
         </p:nvCxnSpPr>
@@ -7489,7 +7575,7 @@
       </p:cxnSp>
       <p:cxnSp>
         <p:nvCxnSpPr>
-          <p:cNvPr id="34" name=""/>
+          <p:cNvPr id="70" name=""/>
           <p:cNvCxnSpPr/>
           <p:nvPr/>
         </p:nvCxnSpPr>
@@ -7511,7 +7597,7 @@
       </p:cxnSp>
       <p:cxnSp>
         <p:nvCxnSpPr>
-          <p:cNvPr id="35" name=""/>
+          <p:cNvPr id="71" name=""/>
           <p:cNvCxnSpPr/>
           <p:nvPr/>
         </p:nvCxnSpPr>
@@ -7533,7 +7619,7 @@
       </p:cxnSp>
       <p:cxnSp>
         <p:nvCxnSpPr>
-          <p:cNvPr id="36" name=""/>
+          <p:cNvPr id="72" name=""/>
           <p:cNvCxnSpPr/>
           <p:nvPr/>
         </p:nvCxnSpPr>
@@ -7555,7 +7641,7 @@
       </p:cxnSp>
       <p:cxnSp>
         <p:nvCxnSpPr>
-          <p:cNvPr id="37" name=""/>
+          <p:cNvPr id="73" name=""/>
           <p:cNvCxnSpPr/>
           <p:nvPr/>
         </p:nvCxnSpPr>
@@ -7577,7 +7663,7 @@
       </p:cxnSp>
       <p:cxnSp>
         <p:nvCxnSpPr>
-          <p:cNvPr id="38" name=""/>
+          <p:cNvPr id="74" name=""/>
           <p:cNvCxnSpPr/>
           <p:nvPr/>
         </p:nvCxnSpPr>
@@ -7599,7 +7685,7 @@
       </p:cxnSp>
       <p:cxnSp>
         <p:nvCxnSpPr>
-          <p:cNvPr id="39" name=""/>
+          <p:cNvPr id="75" name=""/>
           <p:cNvCxnSpPr/>
           <p:nvPr/>
         </p:nvCxnSpPr>
@@ -7621,7 +7707,7 @@
       </p:cxnSp>
       <p:cxnSp>
         <p:nvCxnSpPr>
-          <p:cNvPr id="40" name=""/>
+          <p:cNvPr id="76" name=""/>
           <p:cNvCxnSpPr/>
           <p:nvPr/>
         </p:nvCxnSpPr>
@@ -7704,6 +7790,7 @@
           <a:lstStyle xmlns:a="http://schemas.openxmlformats.org/drawingml/2006/main"/>
           <a:p xmlns:a="http://schemas.openxmlformats.org/drawingml/2006/main">
             <a:pPr algn="l">
+              <a:buNone/>
               <a:defRPr sz="2100" b="1">
                 <a:solidFill>
                   <a:srgbClr val="B76043"/>
@@ -7749,6 +7836,7 @@
           <a:lstStyle xmlns:a="http://schemas.openxmlformats.org/drawingml/2006/main"/>
           <a:p xmlns:a="http://schemas.openxmlformats.org/drawingml/2006/main">
             <a:pPr algn="l">
+              <a:buNone/>
               <a:defRPr sz="2100" b="1">
                 <a:solidFill>
                   <a:srgbClr val="667E95"/>
@@ -7794,6 +7882,7 @@
           <a:lstStyle xmlns:a="http://schemas.openxmlformats.org/drawingml/2006/main"/>
           <a:p xmlns:a="http://schemas.openxmlformats.org/drawingml/2006/main">
             <a:pPr algn="ctr">
+              <a:buNone/>
               <a:defRPr sz="1875" b="1">
                 <a:solidFill>
                   <a:srgbClr val="24211D"/>
@@ -7868,6 +7957,7 @@
           <a:lstStyle xmlns:a="http://schemas.openxmlformats.org/drawingml/2006/main"/>
           <a:p xmlns:a="http://schemas.openxmlformats.org/drawingml/2006/main">
             <a:pPr algn="l">
+              <a:buNone/>
               <a:defRPr sz="1125" b="1">
                 <a:solidFill>
                   <a:srgbClr val="B76043"/>
@@ -7878,7 +7968,7 @@
               </a:defRPr>
             </a:pPr>
             <a:r>
-              <a:t>OUTLOOK SIGNALS</a:t>
+              <a:t>OUTLOOK AI SIGNALS</a:t>
             </a:r>
           </a:p>
         </p:txBody>
@@ -7913,6 +8003,7 @@
           <a:lstStyle xmlns:a="http://schemas.openxmlformats.org/drawingml/2006/main"/>
           <a:p xmlns:a="http://schemas.openxmlformats.org/drawingml/2006/main">
             <a:pPr algn="l">
+              <a:buNone/>
               <a:defRPr sz="3150" b="1">
                 <a:solidFill>
                   <a:srgbClr val="24211D"/>
@@ -7930,7 +8021,7 @@
       </p:sp>
       <p:cxnSp>
         <p:nvCxnSpPr>
-          <p:cNvPr id="26" name=""/>
+          <p:cNvPr id="40" name=""/>
           <p:cNvCxnSpPr/>
           <p:nvPr/>
         </p:nvCxnSpPr>
@@ -7980,6 +8071,7 @@
           <a:lstStyle xmlns:a="http://schemas.openxmlformats.org/drawingml/2006/main"/>
           <a:p xmlns:a="http://schemas.openxmlformats.org/drawingml/2006/main">
             <a:pPr algn="r">
+              <a:buNone/>
               <a:defRPr sz="1050" b="0">
                 <a:solidFill>
                   <a:srgbClr val="716B63"/>
@@ -7997,7 +8089,7 @@
       </p:sp>
       <p:cxnSp>
         <p:nvCxnSpPr>
-          <p:cNvPr id="28" name=""/>
+          <p:cNvPr id="42" name=""/>
           <p:cNvCxnSpPr/>
           <p:nvPr/>
         </p:nvCxnSpPr>
@@ -8019,7 +8111,7 @@
       </p:cxnSp>
       <p:cxnSp>
         <p:nvCxnSpPr>
-          <p:cNvPr id="29" name=""/>
+          <p:cNvPr id="43" name=""/>
           <p:cNvCxnSpPr/>
           <p:nvPr/>
         </p:nvCxnSpPr>
@@ -8041,7 +8133,7 @@
       </p:cxnSp>
       <p:cxnSp>
         <p:nvCxnSpPr>
-          <p:cNvPr id="30" name=""/>
+          <p:cNvPr id="44" name=""/>
           <p:cNvCxnSpPr/>
           <p:nvPr/>
         </p:nvCxnSpPr>
@@ -8124,6 +8216,7 @@
           <a:lstStyle xmlns:a="http://schemas.openxmlformats.org/drawingml/2006/main"/>
           <a:p xmlns:a="http://schemas.openxmlformats.org/drawingml/2006/main">
             <a:pPr algn="ctr">
+              <a:buNone/>
               <a:defRPr sz="1500" b="1">
                 <a:solidFill>
                   <a:srgbClr val="FFFFFF"/>
@@ -8169,6 +8262,7 @@
           <a:lstStyle xmlns:a="http://schemas.openxmlformats.org/drawingml/2006/main"/>
           <a:p xmlns:a="http://schemas.openxmlformats.org/drawingml/2006/main">
             <a:pPr algn="ctr">
+              <a:buNone/>
               <a:defRPr sz="2025" b="1">
                 <a:solidFill>
                   <a:srgbClr val="24211D"/>
@@ -8214,6 +8308,7 @@
           <a:lstStyle xmlns:a="http://schemas.openxmlformats.org/drawingml/2006/main"/>
           <a:p xmlns:a="http://schemas.openxmlformats.org/drawingml/2006/main">
             <a:pPr algn="ctr">
+              <a:buNone/>
               <a:defRPr sz="1425" b="0">
                 <a:solidFill>
                   <a:srgbClr val="716B63"/>
@@ -8293,6 +8388,7 @@
           <a:lstStyle xmlns:a="http://schemas.openxmlformats.org/drawingml/2006/main"/>
           <a:p xmlns:a="http://schemas.openxmlformats.org/drawingml/2006/main">
             <a:pPr algn="ctr">
+              <a:buNone/>
               <a:defRPr sz="1500" b="1">
                 <a:solidFill>
                   <a:srgbClr val="FFFFFF"/>
@@ -8338,6 +8434,7 @@
           <a:lstStyle xmlns:a="http://schemas.openxmlformats.org/drawingml/2006/main"/>
           <a:p xmlns:a="http://schemas.openxmlformats.org/drawingml/2006/main">
             <a:pPr algn="ctr">
+              <a:buNone/>
               <a:defRPr sz="2025" b="1">
                 <a:solidFill>
                   <a:srgbClr val="24211D"/>
@@ -8383,6 +8480,7 @@
           <a:lstStyle xmlns:a="http://schemas.openxmlformats.org/drawingml/2006/main"/>
           <a:p xmlns:a="http://schemas.openxmlformats.org/drawingml/2006/main">
             <a:pPr algn="ctr">
+              <a:buNone/>
               <a:defRPr sz="1425" b="0">
                 <a:solidFill>
                   <a:srgbClr val="716B63"/>
@@ -8462,6 +8560,7 @@
           <a:lstStyle xmlns:a="http://schemas.openxmlformats.org/drawingml/2006/main"/>
           <a:p xmlns:a="http://schemas.openxmlformats.org/drawingml/2006/main">
             <a:pPr algn="ctr">
+              <a:buNone/>
               <a:defRPr sz="1500" b="1">
                 <a:solidFill>
                   <a:srgbClr val="FFFFFF"/>
@@ -8507,6 +8606,7 @@
           <a:lstStyle xmlns:a="http://schemas.openxmlformats.org/drawingml/2006/main"/>
           <a:p xmlns:a="http://schemas.openxmlformats.org/drawingml/2006/main">
             <a:pPr algn="ctr">
+              <a:buNone/>
               <a:defRPr sz="2025" b="1">
                 <a:solidFill>
                   <a:srgbClr val="24211D"/>
@@ -8552,6 +8652,7 @@
           <a:lstStyle xmlns:a="http://schemas.openxmlformats.org/drawingml/2006/main"/>
           <a:p xmlns:a="http://schemas.openxmlformats.org/drawingml/2006/main">
             <a:pPr algn="ctr">
+              <a:buNone/>
               <a:defRPr sz="1425" b="0">
                 <a:solidFill>
                   <a:srgbClr val="716B63"/>
@@ -8631,6 +8732,7 @@
           <a:lstStyle xmlns:a="http://schemas.openxmlformats.org/drawingml/2006/main"/>
           <a:p xmlns:a="http://schemas.openxmlformats.org/drawingml/2006/main">
             <a:pPr algn="ctr">
+              <a:buNone/>
               <a:defRPr sz="1500" b="1">
                 <a:solidFill>
                   <a:srgbClr val="FFFFFF"/>
@@ -8676,6 +8778,7 @@
           <a:lstStyle xmlns:a="http://schemas.openxmlformats.org/drawingml/2006/main"/>
           <a:p xmlns:a="http://schemas.openxmlformats.org/drawingml/2006/main">
             <a:pPr algn="ctr">
+              <a:buNone/>
               <a:defRPr sz="2025" b="1">
                 <a:solidFill>
                   <a:srgbClr val="24211D"/>
@@ -8721,6 +8824,7 @@
           <a:lstStyle xmlns:a="http://schemas.openxmlformats.org/drawingml/2006/main"/>
           <a:p xmlns:a="http://schemas.openxmlformats.org/drawingml/2006/main">
             <a:pPr algn="ctr">
+              <a:buNone/>
               <a:defRPr sz="1425" b="0">
                 <a:solidFill>
                   <a:srgbClr val="716B63"/>
@@ -8796,6 +8900,7 @@
           <a:lstStyle xmlns:a="http://schemas.openxmlformats.org/drawingml/2006/main"/>
           <a:p xmlns:a="http://schemas.openxmlformats.org/drawingml/2006/main">
             <a:pPr algn="l">
+              <a:buNone/>
               <a:defRPr sz="1125" b="1">
                 <a:solidFill>
                   <a:srgbClr val="B76043"/>
@@ -8806,7 +8911,7 @@
               </a:defRPr>
             </a:pPr>
             <a:r>
-              <a:t>OUTLOOK SIGNALS</a:t>
+              <a:t>OUTLOOK AI SIGNALS</a:t>
             </a:r>
           </a:p>
         </p:txBody>
@@ -8841,6 +8946,7 @@
           <a:lstStyle xmlns:a="http://schemas.openxmlformats.org/drawingml/2006/main"/>
           <a:p xmlns:a="http://schemas.openxmlformats.org/drawingml/2006/main">
             <a:pPr algn="l">
+              <a:buNone/>
               <a:defRPr sz="3150" b="1">
                 <a:solidFill>
                   <a:srgbClr val="24211D"/>
@@ -8858,7 +8964,7 @@
       </p:sp>
       <p:cxnSp>
         <p:nvCxnSpPr>
-          <p:cNvPr id="20" name=""/>
+          <p:cNvPr id="26" name=""/>
           <p:cNvCxnSpPr/>
           <p:nvPr/>
         </p:nvCxnSpPr>
@@ -8908,6 +9014,7 @@
           <a:lstStyle xmlns:a="http://schemas.openxmlformats.org/drawingml/2006/main"/>
           <a:p xmlns:a="http://schemas.openxmlformats.org/drawingml/2006/main">
             <a:pPr algn="r">
+              <a:buNone/>
               <a:defRPr sz="1050" b="0">
                 <a:solidFill>
                   <a:srgbClr val="716B63"/>
@@ -9021,6 +9128,7 @@
           <a:lstStyle xmlns:a="http://schemas.openxmlformats.org/drawingml/2006/main"/>
           <a:p xmlns:a="http://schemas.openxmlformats.org/drawingml/2006/main">
             <a:pPr algn="ctr">
+              <a:buNone/>
               <a:defRPr sz="3600" b="1">
                 <a:solidFill>
                   <a:srgbClr val="FFFFFF"/>
@@ -9066,6 +9174,7 @@
           <a:lstStyle xmlns:a="http://schemas.openxmlformats.org/drawingml/2006/main"/>
           <a:p xmlns:a="http://schemas.openxmlformats.org/drawingml/2006/main">
             <a:pPr algn="ctr">
+              <a:buNone/>
               <a:defRPr sz="2025" b="1">
                 <a:solidFill>
                   <a:srgbClr val="FFFFFF"/>
@@ -9111,6 +9220,7 @@
           <a:lstStyle xmlns:a="http://schemas.openxmlformats.org/drawingml/2006/main"/>
           <a:p xmlns:a="http://schemas.openxmlformats.org/drawingml/2006/main">
             <a:pPr algn="ctr">
+              <a:buNone/>
               <a:defRPr sz="1350" b="0">
                 <a:solidFill>
                   <a:srgbClr val="F1DDD3"/>
@@ -9156,6 +9266,7 @@
           <a:lstStyle xmlns:a="http://schemas.openxmlformats.org/drawingml/2006/main"/>
           <a:p xmlns:a="http://schemas.openxmlformats.org/drawingml/2006/main">
             <a:pPr algn="l">
+              <a:buNone/>
               <a:defRPr sz="1800" b="1">
                 <a:solidFill>
                   <a:srgbClr val="B76043"/>
@@ -9201,6 +9312,7 @@
           <a:lstStyle xmlns:a="http://schemas.openxmlformats.org/drawingml/2006/main"/>
           <a:p xmlns:a="http://schemas.openxmlformats.org/drawingml/2006/main">
             <a:pPr algn="l">
+              <a:buNone/>
               <a:defRPr sz="1350" b="1">
                 <a:solidFill>
                   <a:srgbClr val="B76043"/>
@@ -9246,6 +9358,7 @@
           <a:lstStyle xmlns:a="http://schemas.openxmlformats.org/drawingml/2006/main"/>
           <a:p xmlns:a="http://schemas.openxmlformats.org/drawingml/2006/main">
             <a:pPr algn="l">
+              <a:buNone/>
               <a:defRPr sz="1575" b="1">
                 <a:solidFill>
                   <a:srgbClr val="24211D"/>
@@ -9292,6 +9405,7 @@
           <a:lstStyle xmlns:a="http://schemas.openxmlformats.org/drawingml/2006/main"/>
           <a:p xmlns:a="http://schemas.openxmlformats.org/drawingml/2006/main">
             <a:pPr algn="l">
+              <a:buNone/>
               <a:defRPr sz="1350" b="1">
                 <a:solidFill>
                   <a:srgbClr val="667E95"/>
@@ -9337,6 +9451,7 @@
           <a:lstStyle xmlns:a="http://schemas.openxmlformats.org/drawingml/2006/main"/>
           <a:p xmlns:a="http://schemas.openxmlformats.org/drawingml/2006/main">
             <a:pPr algn="l">
+              <a:buNone/>
               <a:defRPr sz="1575" b="1">
                 <a:solidFill>
                   <a:srgbClr val="24211D"/>
@@ -9383,6 +9498,7 @@
           <a:lstStyle xmlns:a="http://schemas.openxmlformats.org/drawingml/2006/main"/>
           <a:p xmlns:a="http://schemas.openxmlformats.org/drawingml/2006/main">
             <a:pPr algn="l">
+              <a:buNone/>
               <a:defRPr sz="1350" b="1">
                 <a:solidFill>
                   <a:srgbClr val="B76043"/>
@@ -9428,6 +9544,7 @@
           <a:lstStyle xmlns:a="http://schemas.openxmlformats.org/drawingml/2006/main"/>
           <a:p xmlns:a="http://schemas.openxmlformats.org/drawingml/2006/main">
             <a:pPr algn="l">
+              <a:buNone/>
               <a:defRPr sz="1575" b="1">
                 <a:solidFill>
                   <a:srgbClr val="24211D"/>
@@ -9474,6 +9591,7 @@
           <a:lstStyle xmlns:a="http://schemas.openxmlformats.org/drawingml/2006/main"/>
           <a:p xmlns:a="http://schemas.openxmlformats.org/drawingml/2006/main">
             <a:pPr algn="ctr">
+              <a:buNone/>
               <a:defRPr sz="1275" b="0">
                 <a:solidFill>
                   <a:srgbClr val="716B63"/>
@@ -9548,6 +9666,7 @@
           <a:lstStyle xmlns:a="http://schemas.openxmlformats.org/drawingml/2006/main"/>
           <a:p xmlns:a="http://schemas.openxmlformats.org/drawingml/2006/main">
             <a:pPr algn="l">
+              <a:buNone/>
               <a:defRPr sz="1125" b="1">
                 <a:solidFill>
                   <a:srgbClr val="B76043"/>
@@ -9558,7 +9677,7 @@
               </a:defRPr>
             </a:pPr>
             <a:r>
-              <a:t>OUTLOOK SIGNALS</a:t>
+              <a:t>OUTLOOK AI SIGNALS</a:t>
             </a:r>
           </a:p>
         </p:txBody>
@@ -9593,6 +9712,7 @@
           <a:lstStyle xmlns:a="http://schemas.openxmlformats.org/drawingml/2006/main"/>
           <a:p xmlns:a="http://schemas.openxmlformats.org/drawingml/2006/main">
             <a:pPr algn="l">
+              <a:buNone/>
               <a:defRPr sz="3150" b="1">
                 <a:solidFill>
                   <a:srgbClr val="24211D"/>
@@ -9610,7 +9730,7 @@
       </p:sp>
       <p:cxnSp>
         <p:nvCxnSpPr>
-          <p:cNvPr id="35" name=""/>
+          <p:cNvPr id="83" name=""/>
           <p:cNvCxnSpPr/>
           <p:nvPr/>
         </p:nvCxnSpPr>
@@ -9660,6 +9780,7 @@
           <a:lstStyle xmlns:a="http://schemas.openxmlformats.org/drawingml/2006/main"/>
           <a:p xmlns:a="http://schemas.openxmlformats.org/drawingml/2006/main">
             <a:pPr algn="r">
+              <a:buNone/>
               <a:defRPr sz="1050" b="0">
                 <a:solidFill>
                   <a:srgbClr val="716B63"/>
@@ -9740,6 +9861,7 @@
           <a:lstStyle xmlns:a="http://schemas.openxmlformats.org/drawingml/2006/main"/>
           <a:p xmlns:a="http://schemas.openxmlformats.org/drawingml/2006/main">
             <a:pPr algn="l">
+              <a:buNone/>
               <a:defRPr sz="2100" b="1">
                 <a:solidFill>
                   <a:srgbClr val="24211D"/>
@@ -9785,6 +9907,7 @@
           <a:lstStyle xmlns:a="http://schemas.openxmlformats.org/drawingml/2006/main"/>
           <a:p xmlns:a="http://schemas.openxmlformats.org/drawingml/2006/main">
             <a:pPr algn="r">
+              <a:buNone/>
               <a:defRPr sz="1200" b="0">
                 <a:solidFill>
                   <a:srgbClr val="716B63"/>
@@ -9865,6 +9988,7 @@
           <a:lstStyle xmlns:a="http://schemas.openxmlformats.org/drawingml/2006/main"/>
           <a:p xmlns:a="http://schemas.openxmlformats.org/drawingml/2006/main">
             <a:pPr algn="ctr">
+              <a:buNone/>
               <a:defRPr sz="1200" b="1">
                 <a:solidFill>
                   <a:srgbClr val="B76043"/>
@@ -9945,6 +10069,7 @@
           <a:lstStyle xmlns:a="http://schemas.openxmlformats.org/drawingml/2006/main"/>
           <a:p xmlns:a="http://schemas.openxmlformats.org/drawingml/2006/main">
             <a:pPr algn="ctr">
+              <a:buNone/>
               <a:defRPr sz="1200" b="1">
                 <a:solidFill>
                   <a:srgbClr val="716B63"/>
@@ -9962,7 +10087,7 @@
       </p:sp>
       <p:cxnSp>
         <p:nvCxnSpPr>
-          <p:cNvPr id="44" name=""/>
+          <p:cNvPr id="92" name=""/>
           <p:cNvCxnSpPr/>
           <p:nvPr/>
         </p:nvCxnSpPr>
@@ -10012,6 +10137,7 @@
           <a:lstStyle xmlns:a="http://schemas.openxmlformats.org/drawingml/2006/main"/>
           <a:p xmlns:a="http://schemas.openxmlformats.org/drawingml/2006/main">
             <a:pPr algn="l">
+              <a:buNone/>
               <a:defRPr sz="1650" b="1">
                 <a:solidFill>
                   <a:srgbClr val="24211D"/>
@@ -10057,6 +10183,7 @@
           <a:lstStyle xmlns:a="http://schemas.openxmlformats.org/drawingml/2006/main"/>
           <a:p xmlns:a="http://schemas.openxmlformats.org/drawingml/2006/main">
             <a:pPr algn="l">
+              <a:buNone/>
               <a:defRPr sz="1200" b="0">
                 <a:solidFill>
                   <a:srgbClr val="716B63"/>
@@ -10102,6 +10229,7 @@
           <a:lstStyle xmlns:a="http://schemas.openxmlformats.org/drawingml/2006/main"/>
           <a:p xmlns:a="http://schemas.openxmlformats.org/drawingml/2006/main">
             <a:pPr algn="r">
+              <a:buNone/>
               <a:defRPr sz="2100" b="1">
                 <a:solidFill>
                   <a:srgbClr val="B76043"/>
@@ -10147,6 +10275,7 @@
           <a:lstStyle xmlns:a="http://schemas.openxmlformats.org/drawingml/2006/main"/>
           <a:p xmlns:a="http://schemas.openxmlformats.org/drawingml/2006/main">
             <a:pPr algn="r">
+              <a:buNone/>
               <a:defRPr sz="1725" b="1">
                 <a:solidFill>
                   <a:srgbClr val="667E95"/>
@@ -10192,6 +10321,7 @@
           <a:lstStyle xmlns:a="http://schemas.openxmlformats.org/drawingml/2006/main"/>
           <a:p xmlns:a="http://schemas.openxmlformats.org/drawingml/2006/main">
             <a:pPr algn="r">
+              <a:buNone/>
               <a:defRPr sz="1200" b="0">
                 <a:solidFill>
                   <a:srgbClr val="716B63"/>
@@ -10209,7 +10339,7 @@
       </p:sp>
       <p:cxnSp>
         <p:nvCxnSpPr>
-          <p:cNvPr id="50" name=""/>
+          <p:cNvPr id="98" name=""/>
           <p:cNvCxnSpPr/>
           <p:nvPr/>
         </p:nvCxnSpPr>
@@ -10259,6 +10389,7 @@
           <a:lstStyle xmlns:a="http://schemas.openxmlformats.org/drawingml/2006/main"/>
           <a:p xmlns:a="http://schemas.openxmlformats.org/drawingml/2006/main">
             <a:pPr algn="l">
+              <a:buNone/>
               <a:defRPr sz="1650" b="1">
                 <a:solidFill>
                   <a:srgbClr val="24211D"/>
@@ -10304,6 +10435,7 @@
           <a:lstStyle xmlns:a="http://schemas.openxmlformats.org/drawingml/2006/main"/>
           <a:p xmlns:a="http://schemas.openxmlformats.org/drawingml/2006/main">
             <a:pPr algn="l">
+              <a:buNone/>
               <a:defRPr sz="1200" b="0">
                 <a:solidFill>
                   <a:srgbClr val="716B63"/>
@@ -10349,6 +10481,7 @@
           <a:lstStyle xmlns:a="http://schemas.openxmlformats.org/drawingml/2006/main"/>
           <a:p xmlns:a="http://schemas.openxmlformats.org/drawingml/2006/main">
             <a:pPr algn="r">
+              <a:buNone/>
               <a:defRPr sz="2100" b="1">
                 <a:solidFill>
                   <a:srgbClr val="B76043"/>
@@ -10394,6 +10527,7 @@
           <a:lstStyle xmlns:a="http://schemas.openxmlformats.org/drawingml/2006/main"/>
           <a:p xmlns:a="http://schemas.openxmlformats.org/drawingml/2006/main">
             <a:pPr algn="r">
+              <a:buNone/>
               <a:defRPr sz="1725" b="1">
                 <a:solidFill>
                   <a:srgbClr val="667E95"/>
@@ -10439,6 +10573,7 @@
           <a:lstStyle xmlns:a="http://schemas.openxmlformats.org/drawingml/2006/main"/>
           <a:p xmlns:a="http://schemas.openxmlformats.org/drawingml/2006/main">
             <a:pPr algn="r">
+              <a:buNone/>
               <a:defRPr sz="1200" b="0">
                 <a:solidFill>
                   <a:srgbClr val="716B63"/>
@@ -10456,7 +10591,7 @@
       </p:sp>
       <p:cxnSp>
         <p:nvCxnSpPr>
-          <p:cNvPr id="56" name=""/>
+          <p:cNvPr id="104" name=""/>
           <p:cNvCxnSpPr/>
           <p:nvPr/>
         </p:nvCxnSpPr>
@@ -10506,6 +10641,7 @@
           <a:lstStyle xmlns:a="http://schemas.openxmlformats.org/drawingml/2006/main"/>
           <a:p xmlns:a="http://schemas.openxmlformats.org/drawingml/2006/main">
             <a:pPr algn="l">
+              <a:buNone/>
               <a:defRPr sz="1650" b="1">
                 <a:solidFill>
                   <a:srgbClr val="24211D"/>
@@ -10551,6 +10687,7 @@
           <a:lstStyle xmlns:a="http://schemas.openxmlformats.org/drawingml/2006/main"/>
           <a:p xmlns:a="http://schemas.openxmlformats.org/drawingml/2006/main">
             <a:pPr algn="l">
+              <a:buNone/>
               <a:defRPr sz="1200" b="0">
                 <a:solidFill>
                   <a:srgbClr val="716B63"/>
@@ -10596,6 +10733,7 @@
           <a:lstStyle xmlns:a="http://schemas.openxmlformats.org/drawingml/2006/main"/>
           <a:p xmlns:a="http://schemas.openxmlformats.org/drawingml/2006/main">
             <a:pPr algn="r">
+              <a:buNone/>
               <a:defRPr sz="2100" b="1">
                 <a:solidFill>
                   <a:srgbClr val="B76043"/>
@@ -10641,6 +10779,7 @@
           <a:lstStyle xmlns:a="http://schemas.openxmlformats.org/drawingml/2006/main"/>
           <a:p xmlns:a="http://schemas.openxmlformats.org/drawingml/2006/main">
             <a:pPr algn="r">
+              <a:buNone/>
               <a:defRPr sz="1725" b="1">
                 <a:solidFill>
                   <a:srgbClr val="667E95"/>
@@ -10686,6 +10825,7 @@
           <a:lstStyle xmlns:a="http://schemas.openxmlformats.org/drawingml/2006/main"/>
           <a:p xmlns:a="http://schemas.openxmlformats.org/drawingml/2006/main">
             <a:pPr algn="r">
+              <a:buNone/>
               <a:defRPr sz="1200" b="0">
                 <a:solidFill>
                   <a:srgbClr val="716B63"/>
@@ -10766,6 +10906,7 @@
           <a:lstStyle xmlns:a="http://schemas.openxmlformats.org/drawingml/2006/main"/>
           <a:p xmlns:a="http://schemas.openxmlformats.org/drawingml/2006/main">
             <a:pPr algn="l">
+              <a:buNone/>
               <a:defRPr sz="1875" b="1">
                 <a:solidFill>
                   <a:srgbClr val="24211D"/>
@@ -10811,6 +10952,7 @@
           <a:lstStyle xmlns:a="http://schemas.openxmlformats.org/drawingml/2006/main"/>
           <a:p xmlns:a="http://schemas.openxmlformats.org/drawingml/2006/main">
             <a:pPr algn="l">
+              <a:buNone/>
               <a:defRPr sz="1500" b="0">
                 <a:solidFill>
                   <a:srgbClr val="716B63"/>
@@ -10888,6 +11030,7 @@
           <a:lstStyle xmlns:a="http://schemas.openxmlformats.org/drawingml/2006/main"/>
           <a:p xmlns:a="http://schemas.openxmlformats.org/drawingml/2006/main">
             <a:pPr algn="l">
+              <a:buNone/>
               <a:defRPr sz="1125" b="1">
                 <a:solidFill>
                   <a:srgbClr val="B76043"/>
@@ -10898,7 +11041,7 @@
               </a:defRPr>
             </a:pPr>
             <a:r>
-              <a:t>OUTLOOK SIGNALS</a:t>
+              <a:t>OUTLOOK AI SIGNALS</a:t>
             </a:r>
           </a:p>
         </p:txBody>
@@ -10933,6 +11076,7 @@
           <a:lstStyle xmlns:a="http://schemas.openxmlformats.org/drawingml/2006/main"/>
           <a:p xmlns:a="http://schemas.openxmlformats.org/drawingml/2006/main">
             <a:pPr algn="l">
+              <a:buNone/>
               <a:defRPr sz="3150" b="1">
                 <a:solidFill>
                   <a:srgbClr val="24211D"/>
@@ -10950,7 +11094,7 @@
       </p:sp>
       <p:cxnSp>
         <p:nvCxnSpPr>
-          <p:cNvPr id="16" name=""/>
+          <p:cNvPr id="38" name=""/>
           <p:cNvCxnSpPr/>
           <p:nvPr/>
         </p:nvCxnSpPr>
@@ -11000,6 +11144,7 @@
           <a:lstStyle xmlns:a="http://schemas.openxmlformats.org/drawingml/2006/main"/>
           <a:p xmlns:a="http://schemas.openxmlformats.org/drawingml/2006/main">
             <a:pPr algn="r">
+              <a:buNone/>
               <a:defRPr sz="1050" b="0">
                 <a:solidFill>
                   <a:srgbClr val="716B63"/>
@@ -11017,18 +11162,18 @@
       </p:sp>
       <p:pic>
         <p:nvPicPr>
-          <p:cNvPr id="18" name=""/>
+          <p:cNvPr id="40" name=""/>
           <p:cNvPicPr>
             <a:picLocks xmlns:a="http://schemas.openxmlformats.org/drawingml/2006/main" noChangeAspect="1"/>
           </p:cNvPicPr>
           <p:nvPr/>
         </p:nvPicPr>
         <p:blipFill>
-          <a:blip xmlns:r="http://schemas.openxmlformats.org/officeDocument/2006/relationships" xmlns:a="http://schemas.openxmlformats.org/drawingml/2006/main" r:embed="Rdb29d52c60f1470e"/>
+          <a:blip xmlns:r="http://schemas.openxmlformats.org/officeDocument/2006/relationships" xmlns:a="http://schemas.openxmlformats.org/drawingml/2006/main" r:embed="Rb2cbd6974de4406b"/>
           <a:stretch xmlns:a="http://schemas.openxmlformats.org/drawingml/2006/main"/>
         </p:blipFill>
         <p:spPr>
-          <a:xfrm xmlns:a="http://schemas.openxmlformats.org/drawingml/2006/main">
+          <a:xfrm xmlns:a="http://schemas.openxmlformats.org/drawingml/2006/main" flipH="0" flipV="0">
             <a:off x="495300" y="1669256"/>
             <a:ext cx="7239000" cy="4071938"/>
           </a:xfrm>
@@ -11100,6 +11245,7 @@
           <a:lstStyle xmlns:a="http://schemas.openxmlformats.org/drawingml/2006/main"/>
           <a:p xmlns:a="http://schemas.openxmlformats.org/drawingml/2006/main">
             <a:pPr algn="l">
+              <a:buNone/>
               <a:defRPr sz="1800" b="1">
                 <a:solidFill>
                   <a:srgbClr val="B76043"/>
@@ -11145,6 +11291,7 @@
           <a:lstStyle xmlns:a="http://schemas.openxmlformats.org/drawingml/2006/main"/>
           <a:p xmlns:a="http://schemas.openxmlformats.org/drawingml/2006/main">
             <a:pPr algn="l">
+              <a:buNone/>
               <a:defRPr sz="1350" b="0">
                 <a:solidFill>
                   <a:srgbClr val="716B63"/>
@@ -11190,6 +11337,7 @@
           <a:lstStyle xmlns:a="http://schemas.openxmlformats.org/drawingml/2006/main"/>
           <a:p xmlns:a="http://schemas.openxmlformats.org/drawingml/2006/main">
             <a:pPr algn="l">
+              <a:buNone/>
               <a:defRPr sz="4200" b="1">
                 <a:solidFill>
                   <a:srgbClr val="B76043"/>
@@ -11207,7 +11355,7 @@
       </p:sp>
       <p:cxnSp>
         <p:nvCxnSpPr>
-          <p:cNvPr id="23" name=""/>
+          <p:cNvPr id="45" name=""/>
           <p:cNvCxnSpPr/>
           <p:nvPr/>
         </p:nvCxnSpPr>
@@ -11257,6 +11405,7 @@
           <a:lstStyle xmlns:a="http://schemas.openxmlformats.org/drawingml/2006/main"/>
           <a:p xmlns:a="http://schemas.openxmlformats.org/drawingml/2006/main">
             <a:pPr algn="l">
+              <a:buNone/>
               <a:defRPr sz="1950" b="1">
                 <a:solidFill>
                   <a:srgbClr val="B76043"/>
@@ -11302,6 +11451,7 @@
           <a:lstStyle xmlns:a="http://schemas.openxmlformats.org/drawingml/2006/main"/>
           <a:p xmlns:a="http://schemas.openxmlformats.org/drawingml/2006/main">
             <a:pPr algn="l">
+              <a:buNone/>
               <a:defRPr sz="1950" b="1">
                 <a:solidFill>
                   <a:srgbClr val="667E95"/>
@@ -11347,6 +11497,7 @@
           <a:lstStyle xmlns:a="http://schemas.openxmlformats.org/drawingml/2006/main"/>
           <a:p xmlns:a="http://schemas.openxmlformats.org/drawingml/2006/main">
             <a:pPr algn="l">
+              <a:buNone/>
               <a:defRPr sz="1500" b="0">
                 <a:solidFill>
                   <a:srgbClr val="716B63"/>
@@ -11424,6 +11575,7 @@
           <a:lstStyle xmlns:a="http://schemas.openxmlformats.org/drawingml/2006/main"/>
           <a:p xmlns:a="http://schemas.openxmlformats.org/drawingml/2006/main">
             <a:pPr algn="l">
+              <a:buNone/>
               <a:defRPr sz="1125" b="1">
                 <a:solidFill>
                   <a:srgbClr val="B76043"/>
@@ -11434,7 +11586,7 @@
               </a:defRPr>
             </a:pPr>
             <a:r>
-              <a:t>OUTLOOK SIGNALS</a:t>
+              <a:t>OUTLOOK AI SIGNALS</a:t>
             </a:r>
           </a:p>
         </p:txBody>
@@ -11469,6 +11621,7 @@
           <a:lstStyle xmlns:a="http://schemas.openxmlformats.org/drawingml/2006/main"/>
           <a:p xmlns:a="http://schemas.openxmlformats.org/drawingml/2006/main">
             <a:pPr algn="l">
+              <a:buNone/>
               <a:defRPr sz="3150" b="1">
                 <a:solidFill>
                   <a:srgbClr val="24211D"/>
@@ -11486,7 +11639,7 @@
       </p:sp>
       <p:cxnSp>
         <p:nvCxnSpPr>
-          <p:cNvPr id="31" name=""/>
+          <p:cNvPr id="87" name=""/>
           <p:cNvCxnSpPr/>
           <p:nvPr/>
         </p:nvCxnSpPr>
@@ -11536,6 +11689,7 @@
           <a:lstStyle xmlns:a="http://schemas.openxmlformats.org/drawingml/2006/main"/>
           <a:p xmlns:a="http://schemas.openxmlformats.org/drawingml/2006/main">
             <a:pPr algn="r">
+              <a:buNone/>
               <a:defRPr sz="1050" b="0">
                 <a:solidFill>
                   <a:srgbClr val="716B63"/>
@@ -11553,21 +11707,21 @@
       </p:sp>
       <p:pic>
         <p:nvPicPr>
-          <p:cNvPr id="33" name=""/>
+          <p:cNvPr id="89" name=""/>
           <p:cNvPicPr>
             <a:picLocks xmlns:a="http://schemas.openxmlformats.org/drawingml/2006/main" noChangeAspect="1"/>
           </p:cNvPicPr>
           <p:nvPr/>
         </p:nvPicPr>
         <p:blipFill>
-          <a:blip xmlns:r="http://schemas.openxmlformats.org/officeDocument/2006/relationships" xmlns:a="http://schemas.openxmlformats.org/drawingml/2006/main" r:embed="Ree7eb429fcc1413e"/>
+          <a:blip xmlns:r="http://schemas.openxmlformats.org/officeDocument/2006/relationships" xmlns:a="http://schemas.openxmlformats.org/drawingml/2006/main" r:embed="R49ec627c8fc648c4"/>
           <a:srcRect xmlns:a="http://schemas.openxmlformats.org/drawingml/2006/main" l="18378" t="0" r="18378" b="0"/>
           <a:stretch xmlns:a="http://schemas.openxmlformats.org/drawingml/2006/main">
             <a:fillRect l="0" t="0" r="0" b="0"/>
           </a:stretch>
         </p:blipFill>
         <p:spPr>
-          <a:xfrm xmlns:a="http://schemas.openxmlformats.org/drawingml/2006/main">
+          <a:xfrm xmlns:a="http://schemas.openxmlformats.org/drawingml/2006/main" flipH="0" flipV="0">
             <a:off x="7543800" y="1752600"/>
             <a:ext cx="3962400" cy="3524250"/>
           </a:xfrm>
@@ -11611,7 +11765,7 @@
       </p:sp>
       <p:cxnSp>
         <p:nvCxnSpPr>
-          <p:cNvPr id="35" name=""/>
+          <p:cNvPr id="91" name=""/>
           <p:cNvCxnSpPr/>
           <p:nvPr/>
         </p:nvCxnSpPr>
@@ -11633,7 +11787,7 @@
       </p:cxnSp>
       <p:cxnSp>
         <p:nvCxnSpPr>
-          <p:cNvPr id="36" name=""/>
+          <p:cNvPr id="92" name=""/>
           <p:cNvCxnSpPr/>
           <p:nvPr/>
         </p:nvCxnSpPr>
@@ -11655,7 +11809,7 @@
       </p:cxnSp>
       <p:cxnSp>
         <p:nvCxnSpPr>
-          <p:cNvPr id="37" name=""/>
+          <p:cNvPr id="93" name=""/>
           <p:cNvCxnSpPr/>
           <p:nvPr/>
         </p:nvCxnSpPr>
@@ -11740,6 +11894,7 @@
           <a:lstStyle xmlns:a="http://schemas.openxmlformats.org/drawingml/2006/main"/>
           <a:p xmlns:a="http://schemas.openxmlformats.org/drawingml/2006/main">
             <a:pPr algn="l">
+              <a:buNone/>
               <a:defRPr sz="1125" b="1">
                 <a:solidFill>
                   <a:srgbClr val="B76043"/>
@@ -11785,6 +11940,7 @@
           <a:lstStyle xmlns:a="http://schemas.openxmlformats.org/drawingml/2006/main"/>
           <a:p xmlns:a="http://schemas.openxmlformats.org/drawingml/2006/main">
             <a:pPr algn="l">
+              <a:buNone/>
               <a:defRPr sz="1650" b="1">
                 <a:solidFill>
                   <a:srgbClr val="24211D"/>
@@ -11830,6 +11986,7 @@
           <a:lstStyle xmlns:a="http://schemas.openxmlformats.org/drawingml/2006/main"/>
           <a:p xmlns:a="http://schemas.openxmlformats.org/drawingml/2006/main">
             <a:pPr algn="l">
+              <a:buNone/>
               <a:defRPr sz="1350" b="0">
                 <a:solidFill>
                   <a:srgbClr val="716B63"/>
@@ -11912,6 +12069,7 @@
           <a:lstStyle xmlns:a="http://schemas.openxmlformats.org/drawingml/2006/main"/>
           <a:p xmlns:a="http://schemas.openxmlformats.org/drawingml/2006/main">
             <a:pPr algn="l">
+              <a:buNone/>
               <a:defRPr sz="1125" b="1">
                 <a:solidFill>
                   <a:srgbClr val="B76043"/>
@@ -11957,6 +12115,7 @@
           <a:lstStyle xmlns:a="http://schemas.openxmlformats.org/drawingml/2006/main"/>
           <a:p xmlns:a="http://schemas.openxmlformats.org/drawingml/2006/main">
             <a:pPr algn="l">
+              <a:buNone/>
               <a:defRPr sz="1650" b="1">
                 <a:solidFill>
                   <a:srgbClr val="24211D"/>
@@ -12002,6 +12161,7 @@
           <a:lstStyle xmlns:a="http://schemas.openxmlformats.org/drawingml/2006/main"/>
           <a:p xmlns:a="http://schemas.openxmlformats.org/drawingml/2006/main">
             <a:pPr algn="l">
+              <a:buNone/>
               <a:defRPr sz="1350" b="0">
                 <a:solidFill>
                   <a:srgbClr val="716B63"/>
@@ -12083,6 +12243,7 @@
           <a:lstStyle xmlns:a="http://schemas.openxmlformats.org/drawingml/2006/main"/>
           <a:p xmlns:a="http://schemas.openxmlformats.org/drawingml/2006/main">
             <a:pPr algn="l">
+              <a:buNone/>
               <a:defRPr sz="1125" b="1">
                 <a:solidFill>
                   <a:srgbClr val="B76043"/>
@@ -12128,6 +12289,7 @@
           <a:lstStyle xmlns:a="http://schemas.openxmlformats.org/drawingml/2006/main"/>
           <a:p xmlns:a="http://schemas.openxmlformats.org/drawingml/2006/main">
             <a:pPr algn="l">
+              <a:buNone/>
               <a:defRPr sz="1650" b="1">
                 <a:solidFill>
                   <a:srgbClr val="24211D"/>
@@ -12173,6 +12335,7 @@
           <a:lstStyle xmlns:a="http://schemas.openxmlformats.org/drawingml/2006/main"/>
           <a:p xmlns:a="http://schemas.openxmlformats.org/drawingml/2006/main">
             <a:pPr algn="l">
+              <a:buNone/>
               <a:defRPr sz="1350" b="0">
                 <a:solidFill>
                   <a:srgbClr val="716B63"/>
@@ -12254,6 +12417,7 @@
           <a:lstStyle xmlns:a="http://schemas.openxmlformats.org/drawingml/2006/main"/>
           <a:p xmlns:a="http://schemas.openxmlformats.org/drawingml/2006/main">
             <a:pPr algn="l">
+              <a:buNone/>
               <a:defRPr sz="1125" b="1">
                 <a:solidFill>
                   <a:srgbClr val="B76043"/>
@@ -12299,6 +12463,7 @@
           <a:lstStyle xmlns:a="http://schemas.openxmlformats.org/drawingml/2006/main"/>
           <a:p xmlns:a="http://schemas.openxmlformats.org/drawingml/2006/main">
             <a:pPr algn="l">
+              <a:buNone/>
               <a:defRPr sz="1650" b="1">
                 <a:solidFill>
                   <a:srgbClr val="24211D"/>
@@ -12344,6 +12509,7 @@
           <a:lstStyle xmlns:a="http://schemas.openxmlformats.org/drawingml/2006/main"/>
           <a:p xmlns:a="http://schemas.openxmlformats.org/drawingml/2006/main">
             <a:pPr algn="l">
+              <a:buNone/>
               <a:defRPr sz="1350" b="0">
                 <a:solidFill>
                   <a:srgbClr val="716B63"/>
@@ -12390,6 +12556,7 @@
           <a:lstStyle xmlns:a="http://schemas.openxmlformats.org/drawingml/2006/main"/>
           <a:p xmlns:a="http://schemas.openxmlformats.org/drawingml/2006/main">
             <a:pPr algn="ctr">
+              <a:buNone/>
               <a:defRPr sz="1350" b="1">
                 <a:solidFill>
                   <a:srgbClr val="B76043"/>
@@ -12407,7 +12574,7 @@
       </p:sp>
       <p:cxnSp>
         <p:nvCxnSpPr>
-          <p:cNvPr id="55" name=""/>
+          <p:cNvPr id="111" name=""/>
           <p:cNvCxnSpPr/>
           <p:nvPr/>
         </p:nvCxnSpPr>
@@ -12457,6 +12624,7 @@
           <a:lstStyle xmlns:a="http://schemas.openxmlformats.org/drawingml/2006/main"/>
           <a:p xmlns:a="http://schemas.openxmlformats.org/drawingml/2006/main">
             <a:pPr algn="ctr">
+              <a:buNone/>
               <a:defRPr sz="1500" b="0">
                 <a:solidFill>
                   <a:srgbClr val="716B63"/>
@@ -12531,6 +12699,7 @@
           <a:lstStyle xmlns:a="http://schemas.openxmlformats.org/drawingml/2006/main"/>
           <a:p xmlns:a="http://schemas.openxmlformats.org/drawingml/2006/main">
             <a:pPr algn="l">
+              <a:buNone/>
               <a:defRPr sz="1125" b="1">
                 <a:solidFill>
                   <a:srgbClr val="B76043"/>
@@ -12541,7 +12710,7 @@
               </a:defRPr>
             </a:pPr>
             <a:r>
-              <a:t>OUTLOOK SIGNALS</a:t>
+              <a:t>OUTLOOK AI SIGNALS</a:t>
             </a:r>
           </a:p>
         </p:txBody>
@@ -12576,6 +12745,7 @@
           <a:lstStyle xmlns:a="http://schemas.openxmlformats.org/drawingml/2006/main"/>
           <a:p xmlns:a="http://schemas.openxmlformats.org/drawingml/2006/main">
             <a:pPr algn="l">
+              <a:buNone/>
               <a:defRPr sz="3150" b="1">
                 <a:solidFill>
                   <a:srgbClr val="24211D"/>
@@ -12593,7 +12763,7 @@
       </p:sp>
       <p:cxnSp>
         <p:nvCxnSpPr>
-          <p:cNvPr id="21" name=""/>
+          <p:cNvPr id="31" name=""/>
           <p:cNvCxnSpPr/>
           <p:nvPr/>
         </p:nvCxnSpPr>
@@ -12643,6 +12813,7 @@
           <a:lstStyle xmlns:a="http://schemas.openxmlformats.org/drawingml/2006/main"/>
           <a:p xmlns:a="http://schemas.openxmlformats.org/drawingml/2006/main">
             <a:pPr algn="r">
+              <a:buNone/>
               <a:defRPr sz="1050" b="0">
                 <a:solidFill>
                   <a:srgbClr val="716B63"/>
@@ -12660,7 +12831,7 @@
       </p:sp>
       <p:cxnSp>
         <p:nvCxnSpPr>
-          <p:cNvPr id="23" name=""/>
+          <p:cNvPr id="33" name=""/>
           <p:cNvCxnSpPr/>
           <p:nvPr/>
         </p:nvCxnSpPr>
@@ -12780,6 +12951,7 @@
           <a:lstStyle xmlns:a="http://schemas.openxmlformats.org/drawingml/2006/main"/>
           <a:p xmlns:a="http://schemas.openxmlformats.org/drawingml/2006/main">
             <a:pPr algn="l">
+              <a:buNone/>
               <a:defRPr sz="2025" b="1">
                 <a:solidFill>
                   <a:srgbClr val="B76043"/>
@@ -12825,6 +12997,7 @@
           <a:lstStyle xmlns:a="http://schemas.openxmlformats.org/drawingml/2006/main"/>
           <a:p xmlns:a="http://schemas.openxmlformats.org/drawingml/2006/main">
             <a:pPr algn="l">
+              <a:buNone/>
               <a:defRPr sz="1650" b="1">
                 <a:solidFill>
                   <a:srgbClr val="24211D"/>
@@ -12870,6 +13043,7 @@
           <a:lstStyle xmlns:a="http://schemas.openxmlformats.org/drawingml/2006/main"/>
           <a:p xmlns:a="http://schemas.openxmlformats.org/drawingml/2006/main">
             <a:pPr algn="l">
+              <a:buNone/>
               <a:defRPr sz="1500" b="0">
                 <a:solidFill>
                   <a:srgbClr val="716B63"/>
@@ -12953,6 +13127,7 @@
           <a:lstStyle xmlns:a="http://schemas.openxmlformats.org/drawingml/2006/main"/>
           <a:p xmlns:a="http://schemas.openxmlformats.org/drawingml/2006/main">
             <a:pPr algn="ctr">
+              <a:buNone/>
               <a:defRPr sz="1200" b="1">
                 <a:solidFill>
                   <a:srgbClr val="B76043"/>
@@ -12998,6 +13173,7 @@
           <a:lstStyle xmlns:a="http://schemas.openxmlformats.org/drawingml/2006/main"/>
           <a:p xmlns:a="http://schemas.openxmlformats.org/drawingml/2006/main">
             <a:pPr algn="l">
+              <a:buNone/>
               <a:defRPr sz="2025" b="1">
                 <a:solidFill>
                   <a:srgbClr val="667E95"/>
@@ -13043,6 +13219,7 @@
           <a:lstStyle xmlns:a="http://schemas.openxmlformats.org/drawingml/2006/main"/>
           <a:p xmlns:a="http://schemas.openxmlformats.org/drawingml/2006/main">
             <a:pPr algn="l">
+              <a:buNone/>
               <a:defRPr sz="1650" b="1">
                 <a:solidFill>
                   <a:srgbClr val="24211D"/>
@@ -13088,6 +13265,7 @@
           <a:lstStyle xmlns:a="http://schemas.openxmlformats.org/drawingml/2006/main"/>
           <a:p xmlns:a="http://schemas.openxmlformats.org/drawingml/2006/main">
             <a:pPr algn="l">
+              <a:buNone/>
               <a:defRPr sz="1500" b="0">
                 <a:solidFill>
                   <a:srgbClr val="716B63"/>
@@ -13171,6 +13349,7 @@
           <a:lstStyle xmlns:a="http://schemas.openxmlformats.org/drawingml/2006/main"/>
           <a:p xmlns:a="http://schemas.openxmlformats.org/drawingml/2006/main">
             <a:pPr algn="ctr">
+              <a:buNone/>
               <a:defRPr sz="1200" b="1">
                 <a:solidFill>
                   <a:srgbClr val="667E95"/>
@@ -13216,6 +13395,7 @@
           <a:lstStyle xmlns:a="http://schemas.openxmlformats.org/drawingml/2006/main"/>
           <a:p xmlns:a="http://schemas.openxmlformats.org/drawingml/2006/main">
             <a:pPr algn="ctr">
+              <a:buNone/>
               <a:defRPr sz="1650" b="1">
                 <a:solidFill>
                   <a:srgbClr val="B76043"/>

</xml_diff>